<commit_message>
Site: retrait autonomie/recharge/batterie, ajout bouton SOS au dos du bijou, simplification
</commit_message>
<xml_diff>
--- a/JECA_PechaKucha.pptx
+++ b/JECA_PechaKucha.pptx
@@ -521,7 +521,7 @@
           <a:lstStyle/>
           <a:p>
             <a:r>
-              <a:t>JECA Jewelry : des bijoux connectés de géolocalisation pour enfants de 4 à 12 ans. Notre promesse, la sérénité se porte. Vingt images, vingt idées. C'est parti.</a:t>
+              <a:t>JECA Jewelry, des bijoux connectés de géolocalisation pour enfants de 4 à 12 ans. Vingt images, vingt idées, cinq minutes. C'est parti.</a:t>
             </a:r>
           </a:p>
         </p:txBody>
@@ -591,7 +591,7 @@
           <a:lstStyle/>
           <a:p>
             <a:r>
-              <a:t>Le bouton SOS : l'enfant alerte ses parents d'une simple pression.</a:t>
+              <a:t>Deux fonctions clés : le bouton SOS et les zones de sécurité avec alerte automatique.</a:t>
             </a:r>
           </a:p>
         </p:txBody>
@@ -661,7 +661,7 @@
           <a:lstStyle/>
           <a:p>
             <a:r>
-              <a:t>Les zones de sécurité : une alerte automatique dès que l'enfant entre ou sort d'une zone.</a:t>
+              <a:t>Données d'enfants hébergées en France, conformes RGPD.</a:t>
             </a:r>
           </a:p>
         </p:txBody>
@@ -731,7 +731,7 @@
           <a:lstStyle/>
           <a:p>
             <a:r>
-              <a:t>Parce qu'on parle d'enfants : tout est hébergé en France, conforme RGPD.</a:t>
+              <a:t>Trois familles, neuf modèles, or et argent, plus un abonnement de 7 à 10 euros par mois qui active la géolocalisation.</a:t>
             </a:r>
           </a:p>
         </p:txBody>
@@ -801,7 +801,7 @@
           <a:lstStyle/>
           <a:p>
             <a:r>
-              <a:t>Trois familles, neuf modèles, en or et en argent. La même technologie dans chacun.</a:t>
+              <a:t>Notre plateforme : un site e-commerce codé sur mesure plutôt qu'un WiziShop, déployé sur Vercel, hébergé en France.</a:t>
             </a:r>
           </a:p>
         </p:txBody>
@@ -871,7 +871,7 @@
           <a:lstStyle/>
           <a:p>
             <a:r>
-              <a:t>Aucun concurrent ne réunit bijou désirable, GPS autonome et souveraineté des données. C'est notre barrière.</a:t>
+              <a:t>Côté construction : paiement Stripe avec 3 fois sans frais, livraison offerte dès 79 euros, CGV conformes au droit français avec rétractation de 14 jours, et conformité RGPD.</a:t>
             </a:r>
           </a:p>
         </p:txBody>
@@ -941,7 +941,7 @@
           <a:lstStyle/>
           <a:p>
             <a:r>
-              <a:t>La boutique n'est pas une maquette : elle est en ligne, accessible tout de suite.</a:t>
+              <a:t>La fiche produit applique les règles de conversion : SEO, visuels, avis, CTA clair.</a:t>
             </a:r>
           </a:p>
         </p:txBody>
@@ -1011,7 +1011,7 @@
           <a:lstStyle/>
           <a:p>
             <a:r>
-              <a:t>La fiche produit applique toutes les règles de conversion : SEO, visuels, avis, CTA clair.</a:t>
+              <a:t>Notre stratégie SEO repose sur des mots-clés précis comme bracelet GPS enfant, des balises meta optimisées et un blog. Le calendrier éditorial planifie un article par semaine et des posts alignés sur les temps forts : rentrée, Noël.</a:t>
             </a:r>
           </a:p>
         </p:txBody>
@@ -1081,7 +1081,7 @@
           <a:lstStyle/>
           <a:p>
             <a:r>
-              <a:t>Tout a été construit avec l'IA : Claude pour le code, Canva pour les visuels et le film, Python pour l'automatisation.</a:t>
+              <a:t>Quelles IA et en quoi elles ont aidé : Claude a codé tout le site, Canva a créé le logo, les visuels et le film, ChatGPT les textes et le SEO, Python a automatisé la production. Résultat : une vitesse multipliée par dix, sans budget d'agence.</a:t>
             </a:r>
           </a:p>
         </p:txBody>
@@ -1151,7 +1151,7 @@
           <a:lstStyle/>
           <a:p>
             <a:r>
-              <a:t>Modèle hybride : la vente du bijou plus un abonnement récurrent qui finance la géolocalisation.</a:t>
+              <a:t>Aucun concurrent ne réunit bijou désirable, GPS autonome et données en France.</a:t>
             </a:r>
           </a:p>
         </p:txBody>
@@ -1221,7 +1221,7 @@
           <a:lstStyle/>
           <a:p>
             <a:r>
-              <a:t>Sur des hypothèses prudentes : rentable dès l'année 1, et l'abonnement porte la marge à près de 29 % en trois ans.</a:t>
+              <a:t>Nos KPI : le taux de conversion mesure si la boutique transforme les visiteurs ; le coût d'acquisition, ou CAC, dit si la publicité est rentable ; la rétention des abonnés est le cœur de notre modèle récurrent ; et la valeur vie client, la LTV, ce que rapporte un client. On les suit dans un tableau de bord.</a:t>
             </a:r>
           </a:p>
         </p:txBody>
@@ -1291,7 +1291,7 @@
           <a:lstStyle/>
           <a:p>
             <a:r>
-              <a:t>Le point de départ est émotionnel : tout parent a vécu ces secondes de panique où il ne voit plus son enfant.</a:t>
+              <a:t>Le point de départ est émotionnel : la peur de perdre son enfant de vue.</a:t>
             </a:r>
           </a:p>
         </p:txBody>
@@ -1361,7 +1361,7 @@
           <a:lstStyle/>
           <a:p>
             <a:r>
-              <a:t>JECA Jewelry transforme l'inquiétude en sérénité. Le site est en ligne, je vous invite à le visiter. Merci de votre attention.</a:t>
+              <a:t>JECA Jewelry transforme l'inquiétude en sérénité. Le site est en ligne. Merci de votre attention.</a:t>
             </a:r>
           </a:p>
         </p:txBody>
@@ -1431,7 +1431,7 @@
           <a:lstStyle/>
           <a:p>
             <a:r>
-              <a:t>Les solutions existent mais échouent : balises moches qu'on ne porte pas, montres trop chères.</a:t>
+              <a:t>Les solutions existent mais ne sont pas portées : moches ou trop chères.</a:t>
             </a:r>
           </a:p>
         </p:txBody>
@@ -1501,7 +1501,7 @@
           <a:lstStyle/>
           <a:p>
             <a:r>
-              <a:t>Notre conviction fondatrice : la sécurité ne sert à rien si l'objet finit dans un tiroir.</a:t>
+              <a:t>Notre choix produit : un bijou GPS. On part du besoin de sécurité mais on le rend désirable, car un dispositif n'est efficace que s'il est porté.</a:t>
             </a:r>
           </a:p>
         </p:txBody>
@@ -1571,7 +1571,7 @@
           <a:lstStyle/>
           <a:p>
             <a:r>
-              <a:t>Sophie, mère active : concilier carrière et sécurité sans culpabiliser.</a:t>
+              <a:t>Sophie, mère active : sécurité sans culpabiliser.</a:t>
             </a:r>
           </a:p>
         </p:txBody>
@@ -1641,7 +1641,7 @@
           <a:lstStyle/>
           <a:p>
             <a:r>
-              <a:t>Karim, parent célibataire au budget serré : le SOS et le paiement en 3 fois le rassurent.</a:t>
+              <a:t>Karim, parent célibataire : le SOS et le paiement en 3 fois le rassurent.</a:t>
             </a:r>
           </a:p>
         </p:txBody>
@@ -1711,7 +1711,7 @@
           <a:lstStyle/>
           <a:p>
             <a:r>
-              <a:t>Inès, sensible au style : elle veut un vrai bijou, pas un gadget.</a:t>
+              <a:t>Inès, sensible au style : un vrai bijou, pas un gadget.</a:t>
             </a:r>
           </a:p>
         </p:txBody>
@@ -1781,7 +1781,7 @@
           <a:lstStyle/>
           <a:p>
             <a:r>
-              <a:t>Notre solution renverse la logique : on part du bijou désirable, pas de la technologie.</a:t>
+              <a:t>La solution : d'abord un bijou désirable, la technologie est cachée à l'intérieur.</a:t>
             </a:r>
           </a:p>
         </p:txBody>
@@ -1851,7 +1851,7 @@
           <a:lstStyle/>
           <a:p>
             <a:r>
-              <a:t>Première fonction : la géolocalisation en temps réel, pilotée depuis l'application des parents.</a:t>
+              <a:t>La géolocalisation en temps réel, pilotée depuis l'application des parents.</a:t>
             </a:r>
           </a:p>
         </p:txBody>
@@ -5062,7 +5062,7 @@
         <p:spPr>
           <a:xfrm>
             <a:off x="914400" y="4572000"/>
-            <a:ext cx="10362895" cy="1280160"/>
+            <a:ext cx="10362895" cy="1371600"/>
           </a:xfrm>
           <a:prstGeom prst="rect">
             <a:avLst/>
@@ -5086,7 +5086,7 @@
             <a:r>
               <a:rPr sz="1700" b="0" i="0">
                 <a:solidFill>
-                  <a:srgbClr val="E8E2D6"/>
+                  <a:srgbClr val="DDD8CE"/>
                 </a:solidFill>
                 <a:latin typeface="Helvetica Neue"/>
               </a:rPr>
@@ -5109,7 +5109,7 @@
                 </a:solidFill>
                 <a:latin typeface="Helvetica Neue"/>
               </a:rPr>
-              <a:t>Soutenance e-commerce · format PechaKucha (20 × 20 s)</a:t>
+              <a:t>Soutenance e-commerce · PechaKucha (20 × 20 s)</a:t>
             </a:r>
           </a:p>
           <a:p>
@@ -5166,7 +5166,7 @@
             <a:avLst/>
           </a:prstGeom>
           <a:solidFill>
-            <a:srgbClr val="F3EFE8"/>
+            <a:srgbClr val="1F3A5F"/>
           </a:solidFill>
           <a:ln>
             <a:noFill/>
@@ -5197,7 +5197,7 @@
       </p:sp>
       <p:pic>
         <p:nvPicPr>
-          <p:cNvPr id="3" name="Picture 2" descr="c2.jpg"/>
+          <p:cNvPr id="3" name="Picture 2" descr="c3.jpg"/>
           <p:cNvPicPr>
             <a:picLocks noChangeAspect="1"/>
           </p:cNvPicPr>
@@ -5211,7 +5211,7 @@
         </p:blipFill>
         <p:spPr>
           <a:xfrm>
-            <a:off x="7071055" y="0"/>
+            <a:off x="0" y="0"/>
             <a:ext cx="5120640" cy="6858000"/>
           </a:xfrm>
           <a:prstGeom prst="rect">
@@ -5252,7 +5252,7 @@
             <a:r>
               <a:rPr sz="1100" b="1" i="0">
                 <a:solidFill>
-                  <a:srgbClr val="B08D57"/>
+                  <a:srgbClr val="E7C87A"/>
                 </a:solidFill>
                 <a:latin typeface="Helvetica Neue"/>
               </a:rPr>
@@ -5294,7 +5294,7 @@
             <a:r>
               <a:rPr sz="1100" b="1" i="0">
                 <a:solidFill>
-                  <a:srgbClr val="777777"/>
+                  <a:srgbClr val="C9C4BA"/>
                 </a:solidFill>
                 <a:latin typeface="Helvetica Neue"/>
               </a:rPr>
@@ -5312,7 +5312,7 @@
         <p:spPr>
           <a:xfrm>
             <a:off x="502920" y="566928"/>
-            <a:ext cx="7315200" cy="274320"/>
+            <a:ext cx="9144000" cy="274320"/>
           </a:xfrm>
           <a:prstGeom prst="rect">
             <a:avLst/>
@@ -5336,11 +5336,11 @@
             <a:r>
               <a:rPr sz="1200" b="1" i="0">
                 <a:solidFill>
-                  <a:srgbClr val="B08D57"/>
+                  <a:srgbClr val="E7C87A"/>
                 </a:solidFill>
                 <a:latin typeface="Helvetica Neue"/>
               </a:rPr>
-              <a:t>COMMENT · SOS</a:t>
+              <a:t>COMMENT · SOS &amp; ZONES</a:t>
             </a:r>
           </a:p>
         </p:txBody>
@@ -5353,7 +5353,7 @@
         </p:nvSpPr>
         <p:spPr>
           <a:xfrm>
-            <a:off x="640080" y="1371600"/>
+            <a:off x="5532120" y="1371600"/>
             <a:ext cx="5852160" cy="4754880"/>
           </a:xfrm>
           <a:prstGeom prst="rect">
@@ -5376,13 +5376,13 @@
               </a:spcAft>
             </a:pPr>
             <a:r>
-              <a:rPr sz="3300" b="0" i="0">
-                <a:solidFill>
-                  <a:srgbClr val="141414"/>
+              <a:rPr sz="3200" b="0" i="0">
+                <a:solidFill>
+                  <a:srgbClr val="FFFFFF"/>
                 </a:solidFill>
                 <a:latin typeface="Georgia"/>
               </a:rPr>
-              <a:t>Une pression. Vous êtes alerté.</a:t>
+              <a:t>Le SOS au poignet. La zone qui veille.</a:t>
             </a:r>
           </a:p>
           <a:p>
@@ -5397,11 +5397,11 @@
             <a:r>
               <a:rPr sz="1600" b="0" i="0">
                 <a:solidFill>
-                  <a:srgbClr val="444444"/>
+                  <a:srgbClr val="DDD8CE"/>
                 </a:solidFill>
                 <a:latin typeface="Helvetica Neue"/>
               </a:rPr>
-              <a:t>Le bouton SOS est logé dans le bijou.</a:t>
+              <a:t>Bouton SOS : l'enfant alerte d'une pression.</a:t>
             </a:r>
           </a:p>
           <a:p>
@@ -5416,11 +5416,11 @@
             <a:r>
               <a:rPr sz="1600" b="0" i="0">
                 <a:solidFill>
-                  <a:srgbClr val="444444"/>
+                  <a:srgbClr val="DDD8CE"/>
                 </a:solidFill>
                 <a:latin typeface="Helvetica Neue"/>
               </a:rPr>
-              <a:t>L'enfant prévient ses parents d'un simple geste.</a:t>
+              <a:t>Zones de sécurité : alerte s'il quitte l'école.</a:t>
             </a:r>
           </a:p>
           <a:p>
@@ -5435,11 +5435,11 @@
             <a:r>
               <a:rPr sz="1600" b="0" i="0">
                 <a:solidFill>
-                  <a:srgbClr val="444444"/>
+                  <a:srgbClr val="DDD8CE"/>
                 </a:solidFill>
                 <a:latin typeface="Helvetica Neue"/>
               </a:rPr>
-              <a:t>Alerte immédiate, position transmise.</a:t>
+              <a:t>La protection qui veille en silence.</a:t>
             </a:r>
           </a:p>
         </p:txBody>
@@ -5477,7 +5477,7 @@
             <a:avLst/>
           </a:prstGeom>
           <a:solidFill>
-            <a:srgbClr val="1F3A5F"/>
+            <a:srgbClr val="F3EFE8"/>
           </a:solidFill>
           <a:ln>
             <a:noFill/>
@@ -5506,30 +5506,50 @@
           </a:p>
         </p:txBody>
       </p:sp>
-      <p:pic>
-        <p:nvPicPr>
-          <p:cNvPr id="3" name="Picture 2" descr="c2.jpg"/>
-          <p:cNvPicPr>
-            <a:picLocks noChangeAspect="1"/>
-          </p:cNvPicPr>
-          <p:nvPr/>
-        </p:nvPicPr>
-        <p:blipFill>
-          <a:blip r:embed="rId2"/>
-          <a:stretch>
-            <a:fillRect/>
-          </a:stretch>
-        </p:blipFill>
-        <p:spPr>
-          <a:xfrm>
-            <a:off x="0" y="0"/>
-            <a:ext cx="5120640" cy="6858000"/>
-          </a:xfrm>
-          <a:prstGeom prst="rect">
-            <a:avLst/>
-          </a:prstGeom>
-        </p:spPr>
-      </p:pic>
+      <p:sp>
+        <p:nvSpPr>
+          <p:cNvPr id="3" name="Rectangle 2"/>
+          <p:cNvSpPr/>
+          <p:nvPr/>
+        </p:nvSpPr>
+        <p:spPr>
+          <a:xfrm>
+            <a:off x="502920" y="1417320"/>
+            <a:ext cx="822960" cy="38100"/>
+          </a:xfrm>
+          <a:prstGeom prst="rect">
+            <a:avLst/>
+          </a:prstGeom>
+          <a:solidFill>
+            <a:srgbClr val="B08D57"/>
+          </a:solidFill>
+          <a:ln>
+            <a:noFill/>
+          </a:ln>
+          <a:effectLst/>
+        </p:spPr>
+        <p:style>
+          <a:lnRef idx="1">
+            <a:schemeClr val="accent1"/>
+          </a:lnRef>
+          <a:fillRef idx="3">
+            <a:schemeClr val="accent1"/>
+          </a:fillRef>
+          <a:effectRef idx="2">
+            <a:schemeClr val="accent1"/>
+          </a:effectRef>
+          <a:fontRef idx="minor">
+            <a:schemeClr val="lt1"/>
+          </a:fontRef>
+        </p:style>
+        <p:txBody>
+          <a:bodyPr rtlCol="0" anchor="ctr"/>
+          <a:lstStyle/>
+          <a:p>
+            <a:pPr algn="ctr"/>
+          </a:p>
+        </p:txBody>
+      </p:sp>
       <p:sp>
         <p:nvSpPr>
           <p:cNvPr id="4" name="TextBox 3"/>
@@ -5563,7 +5583,7 @@
             <a:r>
               <a:rPr sz="1100" b="1" i="0">
                 <a:solidFill>
-                  <a:srgbClr val="E7C87A"/>
+                  <a:srgbClr val="B08D57"/>
                 </a:solidFill>
                 <a:latin typeface="Helvetica Neue"/>
               </a:rPr>
@@ -5605,7 +5625,7 @@
             <a:r>
               <a:rPr sz="1100" b="1" i="0">
                 <a:solidFill>
-                  <a:srgbClr val="C9C4BA"/>
+                  <a:srgbClr val="777777"/>
                 </a:solidFill>
                 <a:latin typeface="Helvetica Neue"/>
               </a:rPr>
@@ -5623,7 +5643,7 @@
         <p:spPr>
           <a:xfrm>
             <a:off x="502920" y="566928"/>
-            <a:ext cx="7315200" cy="274320"/>
+            <a:ext cx="9144000" cy="274320"/>
           </a:xfrm>
           <a:prstGeom prst="rect">
             <a:avLst/>
@@ -5647,11 +5667,11 @@
             <a:r>
               <a:rPr sz="1200" b="1" i="0">
                 <a:solidFill>
-                  <a:srgbClr val="E7C87A"/>
+                  <a:srgbClr val="B08D57"/>
                 </a:solidFill>
                 <a:latin typeface="Helvetica Neue"/>
               </a:rPr>
-              <a:t>COMMENT · ZONES</a:t>
+              <a:t>CONFIANCE</a:t>
             </a:r>
           </a:p>
         </p:txBody>
@@ -5664,8 +5684,8 @@
         </p:nvSpPr>
         <p:spPr>
           <a:xfrm>
-            <a:off x="5532120" y="1371600"/>
-            <a:ext cx="5852160" cy="4754880"/>
+            <a:off x="502920" y="1783080"/>
+            <a:ext cx="10911535" cy="4023360"/>
           </a:xfrm>
           <a:prstGeom prst="rect">
             <a:avLst/>
@@ -5673,7 +5693,7 @@
           <a:noFill/>
         </p:spPr>
         <p:txBody>
-          <a:bodyPr wrap="square" anchor="ctr">
+          <a:bodyPr wrap="square" anchor="t">
             <a:spAutoFit/>
           </a:bodyPr>
           <a:lstStyle/>
@@ -5683,17 +5703,17 @@
                 <a:spcPts val="0"/>
               </a:spcBef>
               <a:spcAft>
-                <a:spcPts val="1200"/>
-              </a:spcAft>
-            </a:pPr>
-            <a:r>
-              <a:rPr sz="3300" b="0" i="0">
-                <a:solidFill>
-                  <a:srgbClr val="FFFFFF"/>
+                <a:spcPts val="1400"/>
+              </a:spcAft>
+            </a:pPr>
+            <a:r>
+              <a:rPr sz="4000" b="0" i="0">
+                <a:solidFill>
+                  <a:srgbClr val="141414"/>
                 </a:solidFill>
                 <a:latin typeface="Georgia"/>
               </a:rPr>
-              <a:t>Une alerte s'il quitte l'école.</a:t>
+              <a:t>Des données d'enfants qui restent en France.</a:t>
             </a:r>
           </a:p>
           <a:p>
@@ -5702,55 +5722,17 @@
                 <a:spcPts val="0"/>
               </a:spcBef>
               <a:spcAft>
-                <a:spcPts val="800"/>
-              </a:spcAft>
-            </a:pPr>
-            <a:r>
-              <a:rPr sz="1600" b="0" i="0">
-                <a:solidFill>
-                  <a:srgbClr val="DDD8CE"/>
+                <a:spcPts val="600"/>
+              </a:spcAft>
+            </a:pPr>
+            <a:r>
+              <a:rPr sz="1800" b="0" i="0">
+                <a:solidFill>
+                  <a:srgbClr val="444444"/>
                 </a:solidFill>
                 <a:latin typeface="Helvetica Neue"/>
               </a:rPr>
-              <a:t>Définissez des zones : école, maison.</a:t>
-            </a:r>
-          </a:p>
-          <a:p>
-            <a:pPr algn="l">
-              <a:spcBef>
-                <a:spcPts val="0"/>
-              </a:spcBef>
-              <a:spcAft>
-                <a:spcPts val="800"/>
-              </a:spcAft>
-            </a:pPr>
-            <a:r>
-              <a:rPr sz="1600" b="0" i="0">
-                <a:solidFill>
-                  <a:srgbClr val="DDD8CE"/>
-                </a:solidFill>
-                <a:latin typeface="Helvetica Neue"/>
-              </a:rPr>
-              <a:t>Notification dès l'entrée ou la sortie.</a:t>
-            </a:r>
-          </a:p>
-          <a:p>
-            <a:pPr algn="l">
-              <a:spcBef>
-                <a:spcPts val="0"/>
-              </a:spcBef>
-              <a:spcAft>
-                <a:spcPts val="800"/>
-              </a:spcAft>
-            </a:pPr>
-            <a:r>
-              <a:rPr sz="1600" b="0" i="0">
-                <a:solidFill>
-                  <a:srgbClr val="DDD8CE"/>
-                </a:solidFill>
-                <a:latin typeface="Helvetica Neue"/>
-              </a:rPr>
-              <a:t>La surveillance qui veille en silence.</a:t>
+              <a:t>Conçu, assemblé et hébergé en France. Chiffré, conforme RGPD. La confiance n'est pas négociable.</a:t>
             </a:r>
           </a:p>
         </p:txBody>
@@ -5788,7 +5770,7 @@
             <a:avLst/>
           </a:prstGeom>
           <a:solidFill>
-            <a:srgbClr val="F3EFE8"/>
+            <a:srgbClr val="FFFFFF"/>
           </a:solidFill>
           <a:ln>
             <a:noFill/>
@@ -5819,51 +5801,7 @@
       </p:sp>
       <p:sp>
         <p:nvSpPr>
-          <p:cNvPr id="3" name="Rectangle 2"/>
-          <p:cNvSpPr/>
-          <p:nvPr/>
-        </p:nvSpPr>
-        <p:spPr>
-          <a:xfrm>
-            <a:off x="502920" y="1417320"/>
-            <a:ext cx="822960" cy="38100"/>
-          </a:xfrm>
-          <a:prstGeom prst="rect">
-            <a:avLst/>
-          </a:prstGeom>
-          <a:solidFill>
-            <a:srgbClr val="B08D57"/>
-          </a:solidFill>
-          <a:ln>
-            <a:noFill/>
-          </a:ln>
-          <a:effectLst/>
-        </p:spPr>
-        <p:style>
-          <a:lnRef idx="1">
-            <a:schemeClr val="accent1"/>
-          </a:lnRef>
-          <a:fillRef idx="3">
-            <a:schemeClr val="accent1"/>
-          </a:fillRef>
-          <a:effectRef idx="2">
-            <a:schemeClr val="accent1"/>
-          </a:effectRef>
-          <a:fontRef idx="minor">
-            <a:schemeClr val="lt1"/>
-          </a:fontRef>
-        </p:style>
-        <p:txBody>
-          <a:bodyPr rtlCol="0" anchor="ctr"/>
-          <a:lstStyle/>
-          <a:p>
-            <a:pPr algn="ctr"/>
-          </a:p>
-        </p:txBody>
-      </p:sp>
-      <p:sp>
-        <p:nvSpPr>
-          <p:cNvPr id="4" name="TextBox 3"/>
+          <p:cNvPr id="3" name="TextBox 2"/>
           <p:cNvSpPr txBox="1"/>
           <p:nvPr/>
         </p:nvSpPr>
@@ -5905,7 +5843,7 @@
       </p:sp>
       <p:sp>
         <p:nvSpPr>
-          <p:cNvPr id="5" name="TextBox 4"/>
+          <p:cNvPr id="4" name="TextBox 3"/>
           <p:cNvSpPr txBox="1"/>
           <p:nvPr/>
         </p:nvSpPr>
@@ -5947,14 +5885,14 @@
       </p:sp>
       <p:sp>
         <p:nvSpPr>
-          <p:cNvPr id="6" name="TextBox 5"/>
+          <p:cNvPr id="5" name="TextBox 4"/>
           <p:cNvSpPr txBox="1"/>
           <p:nvPr/>
         </p:nvSpPr>
         <p:spPr>
           <a:xfrm>
             <a:off x="502920" y="566928"/>
-            <a:ext cx="7315200" cy="274320"/>
+            <a:ext cx="9144000" cy="274320"/>
           </a:xfrm>
           <a:prstGeom prst="rect">
             <a:avLst/>
@@ -5982,21 +5920,21 @@
                 </a:solidFill>
                 <a:latin typeface="Helvetica Neue"/>
               </a:rPr>
-              <a:t>CONFIANCE</a:t>
-            </a:r>
-          </a:p>
-        </p:txBody>
-      </p:sp>
-      <p:sp>
-        <p:nvSpPr>
-          <p:cNvPr id="7" name="TextBox 6"/>
+              <a:t>LE PRODUIT · LA GAMME</a:t>
+            </a:r>
+          </a:p>
+        </p:txBody>
+      </p:sp>
+      <p:sp>
+        <p:nvSpPr>
+          <p:cNvPr id="6" name="TextBox 5"/>
           <p:cNvSpPr txBox="1"/>
           <p:nvPr/>
         </p:nvSpPr>
         <p:spPr>
           <a:xfrm>
-            <a:off x="502920" y="1783080"/>
-            <a:ext cx="10911535" cy="4023360"/>
+            <a:off x="502920" y="960120"/>
+            <a:ext cx="11185855" cy="731520"/>
           </a:xfrm>
           <a:prstGeom prst="rect">
             <a:avLst/>
@@ -6014,21 +5952,87 @@
                 <a:spcPts val="0"/>
               </a:spcBef>
               <a:spcAft>
-                <a:spcPts val="1400"/>
-              </a:spcAft>
-            </a:pPr>
-            <a:r>
-              <a:rPr sz="4000" b="0" i="0">
+                <a:spcPts val="600"/>
+              </a:spcAft>
+            </a:pPr>
+            <a:r>
+              <a:rPr sz="3000" b="0" i="0">
                 <a:solidFill>
                   <a:srgbClr val="141414"/>
                 </a:solidFill>
                 <a:latin typeface="Georgia"/>
               </a:rPr>
-              <a:t>Des données d'enfants qui restent en France.</a:t>
-            </a:r>
-          </a:p>
-          <a:p>
-            <a:pPr algn="l">
+              <a:t>Trois familles · or &amp; argent · + abonnement</a:t>
+            </a:r>
+          </a:p>
+        </p:txBody>
+      </p:sp>
+      <p:pic>
+        <p:nvPicPr>
+          <p:cNvPr id="7" name="Picture 6" descr="c4.jpg"/>
+          <p:cNvPicPr>
+            <a:picLocks noChangeAspect="1"/>
+          </p:cNvPicPr>
+          <p:nvPr/>
+        </p:nvPicPr>
+        <p:blipFill>
+          <a:blip r:embed="rId2"/>
+          <a:stretch>
+            <a:fillRect/>
+          </a:stretch>
+        </p:blipFill>
+        <p:spPr>
+          <a:xfrm>
+            <a:off x="502920" y="1965960"/>
+            <a:ext cx="3454298" cy="2926080"/>
+          </a:xfrm>
+          <a:prstGeom prst="rect">
+            <a:avLst/>
+          </a:prstGeom>
+        </p:spPr>
+      </p:pic>
+      <p:sp>
+        <p:nvSpPr>
+          <p:cNvPr id="8" name="TextBox 7"/>
+          <p:cNvSpPr txBox="1"/>
+          <p:nvPr/>
+        </p:nvSpPr>
+        <p:spPr>
+          <a:xfrm>
+            <a:off x="502920" y="5001768"/>
+            <a:ext cx="3454298" cy="914400"/>
+          </a:xfrm>
+          <a:prstGeom prst="rect">
+            <a:avLst/>
+          </a:prstGeom>
+          <a:noFill/>
+        </p:spPr>
+        <p:txBody>
+          <a:bodyPr wrap="square" anchor="t">
+            <a:spAutoFit/>
+          </a:bodyPr>
+          <a:lstStyle/>
+          <a:p>
+            <a:pPr algn="ctr">
+              <a:spcBef>
+                <a:spcPts val="0"/>
+              </a:spcBef>
+              <a:spcAft>
+                <a:spcPts val="200"/>
+              </a:spcAft>
+            </a:pPr>
+            <a:r>
+              <a:rPr sz="1600" b="1" i="0">
+                <a:solidFill>
+                  <a:srgbClr val="141414"/>
+                </a:solidFill>
+                <a:latin typeface="Georgia"/>
+              </a:rPr>
+              <a:t>Bracelets</a:t>
+            </a:r>
+          </a:p>
+          <a:p>
+            <a:pPr algn="ctr">
               <a:spcBef>
                 <a:spcPts val="0"/>
               </a:spcBef>
@@ -6037,13 +6041,183 @@
               </a:spcAft>
             </a:pPr>
             <a:r>
-              <a:rPr sz="1800" b="0" i="0">
-                <a:solidFill>
-                  <a:srgbClr val="777777"/>
+              <a:rPr sz="1300" b="0" i="0">
+                <a:solidFill>
+                  <a:srgbClr val="B08D57"/>
                 </a:solidFill>
                 <a:latin typeface="Helvetica Neue"/>
               </a:rPr>
-              <a:t>Conçu, assemblé et hébergé en France. Chiffré, conforme RGPD. La confiance n'est pas négociable.</a:t>
+              <a:t>79 – 99 €</a:t>
+            </a:r>
+          </a:p>
+        </p:txBody>
+      </p:sp>
+      <p:pic>
+        <p:nvPicPr>
+          <p:cNvPr id="9" name="Picture 8" descr="c5.jpg"/>
+          <p:cNvPicPr>
+            <a:picLocks noChangeAspect="1"/>
+          </p:cNvPicPr>
+          <p:nvPr/>
+        </p:nvPicPr>
+        <p:blipFill>
+          <a:blip r:embed="rId3"/>
+          <a:stretch>
+            <a:fillRect/>
+          </a:stretch>
+        </p:blipFill>
+        <p:spPr>
+          <a:xfrm>
+            <a:off x="4368698" y="1965960"/>
+            <a:ext cx="3454298" cy="2926080"/>
+          </a:xfrm>
+          <a:prstGeom prst="rect">
+            <a:avLst/>
+          </a:prstGeom>
+        </p:spPr>
+      </p:pic>
+      <p:sp>
+        <p:nvSpPr>
+          <p:cNvPr id="10" name="TextBox 9"/>
+          <p:cNvSpPr txBox="1"/>
+          <p:nvPr/>
+        </p:nvSpPr>
+        <p:spPr>
+          <a:xfrm>
+            <a:off x="4368698" y="5001768"/>
+            <a:ext cx="3454298" cy="914400"/>
+          </a:xfrm>
+          <a:prstGeom prst="rect">
+            <a:avLst/>
+          </a:prstGeom>
+          <a:noFill/>
+        </p:spPr>
+        <p:txBody>
+          <a:bodyPr wrap="square" anchor="t">
+            <a:spAutoFit/>
+          </a:bodyPr>
+          <a:lstStyle/>
+          <a:p>
+            <a:pPr algn="ctr">
+              <a:spcBef>
+                <a:spcPts val="0"/>
+              </a:spcBef>
+              <a:spcAft>
+                <a:spcPts val="200"/>
+              </a:spcAft>
+            </a:pPr>
+            <a:r>
+              <a:rPr sz="1600" b="1" i="0">
+                <a:solidFill>
+                  <a:srgbClr val="141414"/>
+                </a:solidFill>
+                <a:latin typeface="Georgia"/>
+              </a:rPr>
+              <a:t>Colliers</a:t>
+            </a:r>
+          </a:p>
+          <a:p>
+            <a:pPr algn="ctr">
+              <a:spcBef>
+                <a:spcPts val="0"/>
+              </a:spcBef>
+              <a:spcAft>
+                <a:spcPts val="600"/>
+              </a:spcAft>
+            </a:pPr>
+            <a:r>
+              <a:rPr sz="1300" b="0" i="0">
+                <a:solidFill>
+                  <a:srgbClr val="B08D57"/>
+                </a:solidFill>
+                <a:latin typeface="Helvetica Neue"/>
+              </a:rPr>
+              <a:t>89 – 109 €</a:t>
+            </a:r>
+          </a:p>
+        </p:txBody>
+      </p:sp>
+      <p:pic>
+        <p:nvPicPr>
+          <p:cNvPr id="11" name="Picture 10" descr="c6.jpg"/>
+          <p:cNvPicPr>
+            <a:picLocks noChangeAspect="1"/>
+          </p:cNvPicPr>
+          <p:nvPr/>
+        </p:nvPicPr>
+        <p:blipFill>
+          <a:blip r:embed="rId4"/>
+          <a:stretch>
+            <a:fillRect/>
+          </a:stretch>
+        </p:blipFill>
+        <p:spPr>
+          <a:xfrm>
+            <a:off x="8234476" y="1965960"/>
+            <a:ext cx="3454298" cy="2926080"/>
+          </a:xfrm>
+          <a:prstGeom prst="rect">
+            <a:avLst/>
+          </a:prstGeom>
+        </p:spPr>
+      </p:pic>
+      <p:sp>
+        <p:nvSpPr>
+          <p:cNvPr id="12" name="TextBox 11"/>
+          <p:cNvSpPr txBox="1"/>
+          <p:nvPr/>
+        </p:nvSpPr>
+        <p:spPr>
+          <a:xfrm>
+            <a:off x="8234476" y="5001768"/>
+            <a:ext cx="3454298" cy="914400"/>
+          </a:xfrm>
+          <a:prstGeom prst="rect">
+            <a:avLst/>
+          </a:prstGeom>
+          <a:noFill/>
+        </p:spPr>
+        <p:txBody>
+          <a:bodyPr wrap="square" anchor="t">
+            <a:spAutoFit/>
+          </a:bodyPr>
+          <a:lstStyle/>
+          <a:p>
+            <a:pPr algn="ctr">
+              <a:spcBef>
+                <a:spcPts val="0"/>
+              </a:spcBef>
+              <a:spcAft>
+                <a:spcPts val="200"/>
+              </a:spcAft>
+            </a:pPr>
+            <a:r>
+              <a:rPr sz="1600" b="1" i="0">
+                <a:solidFill>
+                  <a:srgbClr val="141414"/>
+                </a:solidFill>
+                <a:latin typeface="Georgia"/>
+              </a:rPr>
+              <a:t>Boucles</a:t>
+            </a:r>
+          </a:p>
+          <a:p>
+            <a:pPr algn="ctr">
+              <a:spcBef>
+                <a:spcPts val="0"/>
+              </a:spcBef>
+              <a:spcAft>
+                <a:spcPts val="600"/>
+              </a:spcAft>
+            </a:pPr>
+            <a:r>
+              <a:rPr sz="1300" b="0" i="0">
+                <a:solidFill>
+                  <a:srgbClr val="B08D57"/>
+                </a:solidFill>
+                <a:latin typeface="Helvetica Neue"/>
+              </a:rPr>
+              <a:t>69 – 89 €</a:t>
             </a:r>
           </a:p>
         </p:txBody>
@@ -6081,7 +6255,7 @@
             <a:avLst/>
           </a:prstGeom>
           <a:solidFill>
-            <a:srgbClr val="FFFFFF"/>
+            <a:srgbClr val="F3EFE8"/>
           </a:solidFill>
           <a:ln>
             <a:noFill/>
@@ -6110,177 +6284,9 @@
           </a:p>
         </p:txBody>
       </p:sp>
-      <p:sp>
-        <p:nvSpPr>
-          <p:cNvPr id="3" name="TextBox 2"/>
-          <p:cNvSpPr txBox="1"/>
-          <p:nvPr/>
-        </p:nvSpPr>
-        <p:spPr>
-          <a:xfrm>
-            <a:off x="502920" y="292608"/>
-            <a:ext cx="5486400" cy="274320"/>
-          </a:xfrm>
-          <a:prstGeom prst="rect">
-            <a:avLst/>
-          </a:prstGeom>
-          <a:noFill/>
-        </p:spPr>
-        <p:txBody>
-          <a:bodyPr wrap="square" anchor="t">
-            <a:spAutoFit/>
-          </a:bodyPr>
-          <a:lstStyle/>
-          <a:p>
-            <a:pPr algn="l">
-              <a:spcBef>
-                <a:spcPts val="0"/>
-              </a:spcBef>
-              <a:spcAft>
-                <a:spcPts val="600"/>
-              </a:spcAft>
-            </a:pPr>
-            <a:r>
-              <a:rPr sz="1100" b="1" i="0">
-                <a:solidFill>
-                  <a:srgbClr val="B08D57"/>
-                </a:solidFill>
-                <a:latin typeface="Helvetica Neue"/>
-              </a:rPr>
-              <a:t>JECA JEWELRY</a:t>
-            </a:r>
-          </a:p>
-        </p:txBody>
-      </p:sp>
-      <p:sp>
-        <p:nvSpPr>
-          <p:cNvPr id="4" name="TextBox 3"/>
-          <p:cNvSpPr txBox="1"/>
-          <p:nvPr/>
-        </p:nvSpPr>
-        <p:spPr>
-          <a:xfrm>
-            <a:off x="10180015" y="292608"/>
-            <a:ext cx="1508760" cy="274320"/>
-          </a:xfrm>
-          <a:prstGeom prst="rect">
-            <a:avLst/>
-          </a:prstGeom>
-          <a:noFill/>
-        </p:spPr>
-        <p:txBody>
-          <a:bodyPr wrap="square" anchor="t">
-            <a:spAutoFit/>
-          </a:bodyPr>
-          <a:lstStyle/>
-          <a:p>
-            <a:pPr algn="r">
-              <a:spcBef>
-                <a:spcPts val="0"/>
-              </a:spcBef>
-              <a:spcAft>
-                <a:spcPts val="600"/>
-              </a:spcAft>
-            </a:pPr>
-            <a:r>
-              <a:rPr sz="1100" b="1" i="0">
-                <a:solidFill>
-                  <a:srgbClr val="777777"/>
-                </a:solidFill>
-                <a:latin typeface="Helvetica Neue"/>
-              </a:rPr>
-              <a:t>13 / 20</a:t>
-            </a:r>
-          </a:p>
-        </p:txBody>
-      </p:sp>
-      <p:sp>
-        <p:nvSpPr>
-          <p:cNvPr id="5" name="TextBox 4"/>
-          <p:cNvSpPr txBox="1"/>
-          <p:nvPr/>
-        </p:nvSpPr>
-        <p:spPr>
-          <a:xfrm>
-            <a:off x="502920" y="566928"/>
-            <a:ext cx="7315200" cy="274320"/>
-          </a:xfrm>
-          <a:prstGeom prst="rect">
-            <a:avLst/>
-          </a:prstGeom>
-          <a:noFill/>
-        </p:spPr>
-        <p:txBody>
-          <a:bodyPr wrap="square" anchor="t">
-            <a:spAutoFit/>
-          </a:bodyPr>
-          <a:lstStyle/>
-          <a:p>
-            <a:pPr algn="l">
-              <a:spcBef>
-                <a:spcPts val="0"/>
-              </a:spcBef>
-              <a:spcAft>
-                <a:spcPts val="600"/>
-              </a:spcAft>
-            </a:pPr>
-            <a:r>
-              <a:rPr sz="1200" b="1" i="0">
-                <a:solidFill>
-                  <a:srgbClr val="B08D57"/>
-                </a:solidFill>
-                <a:latin typeface="Helvetica Neue"/>
-              </a:rPr>
-              <a:t>LA GAMME</a:t>
-            </a:r>
-          </a:p>
-        </p:txBody>
-      </p:sp>
-      <p:sp>
-        <p:nvSpPr>
-          <p:cNvPr id="6" name="TextBox 5"/>
-          <p:cNvSpPr txBox="1"/>
-          <p:nvPr/>
-        </p:nvSpPr>
-        <p:spPr>
-          <a:xfrm>
-            <a:off x="502920" y="960120"/>
-            <a:ext cx="11185855" cy="731520"/>
-          </a:xfrm>
-          <a:prstGeom prst="rect">
-            <a:avLst/>
-          </a:prstGeom>
-          <a:noFill/>
-        </p:spPr>
-        <p:txBody>
-          <a:bodyPr wrap="square" anchor="t">
-            <a:spAutoFit/>
-          </a:bodyPr>
-          <a:lstStyle/>
-          <a:p>
-            <a:pPr algn="l">
-              <a:spcBef>
-                <a:spcPts val="0"/>
-              </a:spcBef>
-              <a:spcAft>
-                <a:spcPts val="600"/>
-              </a:spcAft>
-            </a:pPr>
-            <a:r>
-              <a:rPr sz="3000" b="0" i="0">
-                <a:solidFill>
-                  <a:srgbClr val="141414"/>
-                </a:solidFill>
-                <a:latin typeface="Georgia"/>
-              </a:rPr>
-              <a:t>Trois familles · or &amp; argent</a:t>
-            </a:r>
-          </a:p>
-        </p:txBody>
-      </p:sp>
       <p:pic>
         <p:nvPicPr>
-          <p:cNvPr id="7" name="Picture 6" descr="c4.jpg"/>
+          <p:cNvPr id="3" name="Picture 2" descr="c7.jpg"/>
           <p:cNvPicPr>
             <a:picLocks noChangeAspect="1"/>
           </p:cNvPicPr>
@@ -6294,8 +6300,8 @@
         </p:blipFill>
         <p:spPr>
           <a:xfrm>
-            <a:off x="502920" y="1965960"/>
-            <a:ext cx="3454298" cy="2926080"/>
+            <a:off x="7071055" y="0"/>
+            <a:ext cx="5120640" cy="6858000"/>
           </a:xfrm>
           <a:prstGeom prst="rect">
             <a:avLst/>
@@ -6304,14 +6310,14 @@
       </p:pic>
       <p:sp>
         <p:nvSpPr>
-          <p:cNvPr id="8" name="TextBox 7"/>
+          <p:cNvPr id="4" name="TextBox 3"/>
           <p:cNvSpPr txBox="1"/>
           <p:nvPr/>
         </p:nvSpPr>
         <p:spPr>
           <a:xfrm>
-            <a:off x="502920" y="5001768"/>
-            <a:ext cx="3454298" cy="914400"/>
+            <a:off x="502920" y="292608"/>
+            <a:ext cx="5486400" cy="274320"/>
           </a:xfrm>
           <a:prstGeom prst="rect">
             <a:avLst/>
@@ -6324,26 +6330,7 @@
           </a:bodyPr>
           <a:lstStyle/>
           <a:p>
-            <a:pPr algn="ctr">
-              <a:spcBef>
-                <a:spcPts val="0"/>
-              </a:spcBef>
-              <a:spcAft>
-                <a:spcPts val="200"/>
-              </a:spcAft>
-            </a:pPr>
-            <a:r>
-              <a:rPr sz="1600" b="1" i="0">
-                <a:solidFill>
-                  <a:srgbClr val="141414"/>
-                </a:solidFill>
-                <a:latin typeface="Georgia"/>
-              </a:rPr>
-              <a:t>Bracelets</a:t>
-            </a:r>
-          </a:p>
-          <a:p>
-            <a:pPr algn="ctr">
+            <a:pPr algn="l">
               <a:spcBef>
                 <a:spcPts val="0"/>
               </a:spcBef>
@@ -6352,51 +6339,27 @@
               </a:spcAft>
             </a:pPr>
             <a:r>
-              <a:rPr sz="1300" b="0" i="0">
+              <a:rPr sz="1100" b="1" i="0">
                 <a:solidFill>
                   <a:srgbClr val="B08D57"/>
                 </a:solidFill>
                 <a:latin typeface="Helvetica Neue"/>
               </a:rPr>
-              <a:t>79 – 99 €</a:t>
-            </a:r>
-          </a:p>
-        </p:txBody>
-      </p:sp>
-      <p:pic>
-        <p:nvPicPr>
-          <p:cNvPr id="9" name="Picture 8" descr="c5.jpg"/>
-          <p:cNvPicPr>
-            <a:picLocks noChangeAspect="1"/>
-          </p:cNvPicPr>
-          <p:nvPr/>
-        </p:nvPicPr>
-        <p:blipFill>
-          <a:blip r:embed="rId3"/>
-          <a:stretch>
-            <a:fillRect/>
-          </a:stretch>
-        </p:blipFill>
-        <p:spPr>
-          <a:xfrm>
-            <a:off x="4368698" y="1965960"/>
-            <a:ext cx="3454298" cy="2926080"/>
-          </a:xfrm>
-          <a:prstGeom prst="rect">
-            <a:avLst/>
-          </a:prstGeom>
-        </p:spPr>
-      </p:pic>
-      <p:sp>
-        <p:nvSpPr>
-          <p:cNvPr id="10" name="TextBox 9"/>
+              <a:t>JECA JEWELRY</a:t>
+            </a:r>
+          </a:p>
+        </p:txBody>
+      </p:sp>
+      <p:sp>
+        <p:nvSpPr>
+          <p:cNvPr id="5" name="TextBox 4"/>
           <p:cNvSpPr txBox="1"/>
           <p:nvPr/>
         </p:nvSpPr>
         <p:spPr>
           <a:xfrm>
-            <a:off x="4368698" y="5001768"/>
-            <a:ext cx="3454298" cy="914400"/>
+            <a:off x="10180015" y="292608"/>
+            <a:ext cx="1508760" cy="274320"/>
           </a:xfrm>
           <a:prstGeom prst="rect">
             <a:avLst/>
@@ -6409,26 +6372,7 @@
           </a:bodyPr>
           <a:lstStyle/>
           <a:p>
-            <a:pPr algn="ctr">
-              <a:spcBef>
-                <a:spcPts val="0"/>
-              </a:spcBef>
-              <a:spcAft>
-                <a:spcPts val="200"/>
-              </a:spcAft>
-            </a:pPr>
-            <a:r>
-              <a:rPr sz="1600" b="1" i="0">
-                <a:solidFill>
-                  <a:srgbClr val="141414"/>
-                </a:solidFill>
-                <a:latin typeface="Georgia"/>
-              </a:rPr>
-              <a:t>Colliers</a:t>
-            </a:r>
-          </a:p>
-          <a:p>
-            <a:pPr algn="ctr">
+            <a:pPr algn="r">
               <a:spcBef>
                 <a:spcPts val="0"/>
               </a:spcBef>
@@ -6437,51 +6381,27 @@
               </a:spcAft>
             </a:pPr>
             <a:r>
-              <a:rPr sz="1300" b="0" i="0">
-                <a:solidFill>
-                  <a:srgbClr val="B08D57"/>
+              <a:rPr sz="1100" b="1" i="0">
+                <a:solidFill>
+                  <a:srgbClr val="777777"/>
                 </a:solidFill>
                 <a:latin typeface="Helvetica Neue"/>
               </a:rPr>
-              <a:t>89 – 109 €</a:t>
-            </a:r>
-          </a:p>
-        </p:txBody>
-      </p:sp>
-      <p:pic>
-        <p:nvPicPr>
-          <p:cNvPr id="11" name="Picture 10" descr="c6.jpg"/>
-          <p:cNvPicPr>
-            <a:picLocks noChangeAspect="1"/>
-          </p:cNvPicPr>
-          <p:nvPr/>
-        </p:nvPicPr>
-        <p:blipFill>
-          <a:blip r:embed="rId4"/>
-          <a:stretch>
-            <a:fillRect/>
-          </a:stretch>
-        </p:blipFill>
-        <p:spPr>
-          <a:xfrm>
-            <a:off x="8234476" y="1965960"/>
-            <a:ext cx="3454298" cy="2926080"/>
-          </a:xfrm>
-          <a:prstGeom prst="rect">
-            <a:avLst/>
-          </a:prstGeom>
-        </p:spPr>
-      </p:pic>
-      <p:sp>
-        <p:nvSpPr>
-          <p:cNvPr id="12" name="TextBox 11"/>
+              <a:t>13 / 20</a:t>
+            </a:r>
+          </a:p>
+        </p:txBody>
+      </p:sp>
+      <p:sp>
+        <p:nvSpPr>
+          <p:cNvPr id="6" name="TextBox 5"/>
           <p:cNvSpPr txBox="1"/>
           <p:nvPr/>
         </p:nvSpPr>
         <p:spPr>
           <a:xfrm>
-            <a:off x="8234476" y="5001768"/>
-            <a:ext cx="3454298" cy="914400"/>
+            <a:off x="502920" y="566928"/>
+            <a:ext cx="9144000" cy="274320"/>
           </a:xfrm>
           <a:prstGeom prst="rect">
             <a:avLst/>
@@ -6494,41 +6414,121 @@
           </a:bodyPr>
           <a:lstStyle/>
           <a:p>
-            <a:pPr algn="ctr">
-              <a:spcBef>
-                <a:spcPts val="0"/>
-              </a:spcBef>
-              <a:spcAft>
-                <a:spcPts val="200"/>
-              </a:spcAft>
-            </a:pPr>
-            <a:r>
-              <a:rPr sz="1600" b="1" i="0">
+            <a:pPr algn="l">
+              <a:spcBef>
+                <a:spcPts val="0"/>
+              </a:spcBef>
+              <a:spcAft>
+                <a:spcPts val="600"/>
+              </a:spcAft>
+            </a:pPr>
+            <a:r>
+              <a:rPr sz="1200" b="1" i="0">
+                <a:solidFill>
+                  <a:srgbClr val="B08D57"/>
+                </a:solidFill>
+                <a:latin typeface="Helvetica Neue"/>
+              </a:rPr>
+              <a:t>E-COMMERCE · LA PLATEFORME</a:t>
+            </a:r>
+          </a:p>
+        </p:txBody>
+      </p:sp>
+      <p:sp>
+        <p:nvSpPr>
+          <p:cNvPr id="7" name="TextBox 6"/>
+          <p:cNvSpPr txBox="1"/>
+          <p:nvPr/>
+        </p:nvSpPr>
+        <p:spPr>
+          <a:xfrm>
+            <a:off x="640080" y="1371600"/>
+            <a:ext cx="5852160" cy="4754880"/>
+          </a:xfrm>
+          <a:prstGeom prst="rect">
+            <a:avLst/>
+          </a:prstGeom>
+          <a:noFill/>
+        </p:spPr>
+        <p:txBody>
+          <a:bodyPr wrap="square" anchor="ctr">
+            <a:spAutoFit/>
+          </a:bodyPr>
+          <a:lstStyle/>
+          <a:p>
+            <a:pPr algn="l">
+              <a:spcBef>
+                <a:spcPts val="0"/>
+              </a:spcBef>
+              <a:spcAft>
+                <a:spcPts val="1200"/>
+              </a:spcAft>
+            </a:pPr>
+            <a:r>
+              <a:rPr sz="3200" b="0" i="0">
                 <a:solidFill>
                   <a:srgbClr val="141414"/>
                 </a:solidFill>
                 <a:latin typeface="Georgia"/>
               </a:rPr>
-              <a:t>Boucles</a:t>
-            </a:r>
-          </a:p>
-          <a:p>
-            <a:pPr algn="ctr">
-              <a:spcBef>
-                <a:spcPts val="0"/>
-              </a:spcBef>
-              <a:spcAft>
-                <a:spcPts val="600"/>
-              </a:spcAft>
-            </a:pPr>
-            <a:r>
-              <a:rPr sz="1300" b="0" i="0">
-                <a:solidFill>
-                  <a:srgbClr val="B08D57"/>
+              <a:t>Une boutique sur-mesure.</a:t>
+            </a:r>
+          </a:p>
+          <a:p>
+            <a:pPr algn="l">
+              <a:spcBef>
+                <a:spcPts val="0"/>
+              </a:spcBef>
+              <a:spcAft>
+                <a:spcPts val="800"/>
+              </a:spcAft>
+            </a:pPr>
+            <a:r>
+              <a:rPr sz="1600" b="0" i="0">
+                <a:solidFill>
+                  <a:srgbClr val="444444"/>
                 </a:solidFill>
                 <a:latin typeface="Helvetica Neue"/>
               </a:rPr>
-              <a:t>69 – 89 €</a:t>
+              <a:t>Pas de WiziShop : un site codé sur-mesure (HTML/CSS/JS).</a:t>
+            </a:r>
+          </a:p>
+          <a:p>
+            <a:pPr algn="l">
+              <a:spcBef>
+                <a:spcPts val="0"/>
+              </a:spcBef>
+              <a:spcAft>
+                <a:spcPts val="800"/>
+              </a:spcAft>
+            </a:pPr>
+            <a:r>
+              <a:rPr sz="1600" b="0" i="0">
+                <a:solidFill>
+                  <a:srgbClr val="444444"/>
+                </a:solidFill>
+                <a:latin typeface="Helvetica Neue"/>
+              </a:rPr>
+              <a:t>14 pages, panier, responsive, rapide.</a:t>
+            </a:r>
+          </a:p>
+          <a:p>
+            <a:pPr algn="l">
+              <a:spcBef>
+                <a:spcPts val="0"/>
+              </a:spcBef>
+              <a:spcAft>
+                <a:spcPts val="800"/>
+              </a:spcAft>
+            </a:pPr>
+            <a:r>
+              <a:rPr sz="1600" b="0" i="0">
+                <a:solidFill>
+                  <a:srgbClr val="444444"/>
+                </a:solidFill>
+                <a:latin typeface="Helvetica Neue"/>
+              </a:rPr>
+              <a:t>Déployée sur Vercel, hébergée en France.</a:t>
             </a:r>
           </a:p>
         </p:txBody>
@@ -6732,7 +6732,7 @@
         <p:spPr>
           <a:xfrm>
             <a:off x="502920" y="566928"/>
-            <a:ext cx="7315200" cy="274320"/>
+            <a:ext cx="9144000" cy="274320"/>
           </a:xfrm>
           <a:prstGeom prst="rect">
             <a:avLst/>
@@ -6760,7 +6760,7 @@
                 </a:solidFill>
                 <a:latin typeface="Helvetica Neue"/>
               </a:rPr>
-              <a:t>LA CONCURRENCE</a:t>
+              <a:t>E-COMMERCE · PAIEMENT, LIVRAISON &amp; CGV</a:t>
             </a:r>
           </a:p>
         </p:txBody>
@@ -6773,8 +6773,8 @@
         </p:nvSpPr>
         <p:spPr>
           <a:xfrm>
-            <a:off x="502920" y="1783080"/>
-            <a:ext cx="10911535" cy="4023360"/>
+            <a:off x="502920" y="1737360"/>
+            <a:ext cx="10911535" cy="914400"/>
           </a:xfrm>
           <a:prstGeom prst="rect">
             <a:avLst/>
@@ -6792,36 +6792,192 @@
                 <a:spcPts val="0"/>
               </a:spcBef>
               <a:spcAft>
-                <a:spcPts val="1400"/>
-              </a:spcAft>
-            </a:pPr>
-            <a:r>
-              <a:rPr sz="4000" b="0" i="0">
+                <a:spcPts val="600"/>
+              </a:spcAft>
+            </a:pPr>
+            <a:r>
+              <a:rPr sz="3400" b="0" i="0">
                 <a:solidFill>
                   <a:srgbClr val="FFFFFF"/>
                 </a:solidFill>
                 <a:latin typeface="Georgia"/>
               </a:rPr>
-              <a:t>Personne n'occupe notre place.</a:t>
-            </a:r>
-          </a:p>
+              <a:t>Sécurisé et conforme.</a:t>
+            </a:r>
+          </a:p>
+        </p:txBody>
+      </p:sp>
+      <p:sp>
+        <p:nvSpPr>
+          <p:cNvPr id="8" name="TextBox 7"/>
+          <p:cNvSpPr txBox="1"/>
+          <p:nvPr/>
+        </p:nvSpPr>
+        <p:spPr>
+          <a:xfrm>
+            <a:off x="502920" y="2743200"/>
+            <a:ext cx="10911535" cy="3657600"/>
+          </a:xfrm>
+          <a:prstGeom prst="rect">
+            <a:avLst/>
+          </a:prstGeom>
+          <a:noFill/>
+        </p:spPr>
+        <p:txBody>
+          <a:bodyPr wrap="square" anchor="t">
+            <a:spAutoFit/>
+          </a:bodyPr>
+          <a:lstStyle/>
           <a:p>
             <a:pPr algn="l">
               <a:spcBef>
-                <a:spcPts val="0"/>
-              </a:spcBef>
-              <a:spcAft>
-                <a:spcPts val="600"/>
-              </a:spcAft>
-            </a:pPr>
-            <a:r>
-              <a:rPr sz="1800" b="0" i="0">
-                <a:solidFill>
-                  <a:srgbClr val="C9C4BA"/>
+                <a:spcPts val="800"/>
+              </a:spcBef>
+              <a:spcAft>
+                <a:spcPts val="100"/>
+              </a:spcAft>
+            </a:pPr>
+            <a:r>
+              <a:rPr sz="1800" b="1" i="0">
+                <a:solidFill>
+                  <a:srgbClr val="E7C87A"/>
                 </a:solidFill>
                 <a:latin typeface="Helvetica Neue"/>
               </a:rPr>
-              <a:t>Weenect : une balise qu'on oublie. Xplora : une montre encombrante. AngelSense : un boîtier médicalisé. JECA : le seul vrai bijou + GPS + données en France.</a:t>
+              <a:t>Paiement</a:t>
+            </a:r>
+          </a:p>
+          <a:p>
+            <a:pPr algn="l">
+              <a:spcBef>
+                <a:spcPts val="0"/>
+              </a:spcBef>
+              <a:spcAft>
+                <a:spcPts val="400"/>
+              </a:spcAft>
+            </a:pPr>
+            <a:r>
+              <a:rPr sz="1500" b="0" i="0">
+                <a:solidFill>
+                  <a:srgbClr val="DDD8CE"/>
+                </a:solidFill>
+                <a:latin typeface="Helvetica Neue"/>
+              </a:rPr>
+              <a:t>Stripe sécurisé, CB + paiement 3× sans frais, HTTPS.</a:t>
+            </a:r>
+          </a:p>
+          <a:p>
+            <a:pPr algn="l">
+              <a:spcBef>
+                <a:spcPts val="800"/>
+              </a:spcBef>
+              <a:spcAft>
+                <a:spcPts val="100"/>
+              </a:spcAft>
+            </a:pPr>
+            <a:r>
+              <a:rPr sz="1800" b="1" i="0">
+                <a:solidFill>
+                  <a:srgbClr val="E7C87A"/>
+                </a:solidFill>
+                <a:latin typeface="Helvetica Neue"/>
+              </a:rPr>
+              <a:t>Livraison</a:t>
+            </a:r>
+          </a:p>
+          <a:p>
+            <a:pPr algn="l">
+              <a:spcBef>
+                <a:spcPts val="0"/>
+              </a:spcBef>
+              <a:spcAft>
+                <a:spcPts val="400"/>
+              </a:spcAft>
+            </a:pPr>
+            <a:r>
+              <a:rPr sz="1500" b="0" i="0">
+                <a:solidFill>
+                  <a:srgbClr val="DDD8CE"/>
+                </a:solidFill>
+                <a:latin typeface="Helvetica Neue"/>
+              </a:rPr>
+              <a:t>72 h, offerte dès 79 €, suivi colis.</a:t>
+            </a:r>
+          </a:p>
+          <a:p>
+            <a:pPr algn="l">
+              <a:spcBef>
+                <a:spcPts val="800"/>
+              </a:spcBef>
+              <a:spcAft>
+                <a:spcPts val="100"/>
+              </a:spcAft>
+            </a:pPr>
+            <a:r>
+              <a:rPr sz="1800" b="1" i="0">
+                <a:solidFill>
+                  <a:srgbClr val="E7C87A"/>
+                </a:solidFill>
+                <a:latin typeface="Helvetica Neue"/>
+              </a:rPr>
+              <a:t>CGV</a:t>
+            </a:r>
+          </a:p>
+          <a:p>
+            <a:pPr algn="l">
+              <a:spcBef>
+                <a:spcPts val="0"/>
+              </a:spcBef>
+              <a:spcAft>
+                <a:spcPts val="400"/>
+              </a:spcAft>
+            </a:pPr>
+            <a:r>
+              <a:rPr sz="1500" b="0" i="0">
+                <a:solidFill>
+                  <a:srgbClr val="DDD8CE"/>
+                </a:solidFill>
+                <a:latin typeface="Helvetica Neue"/>
+              </a:rPr>
+              <a:t>Rétractation 14 j (loi Hamon), garantie légale 2 ans, retours.</a:t>
+            </a:r>
+          </a:p>
+          <a:p>
+            <a:pPr algn="l">
+              <a:spcBef>
+                <a:spcPts val="800"/>
+              </a:spcBef>
+              <a:spcAft>
+                <a:spcPts val="100"/>
+              </a:spcAft>
+            </a:pPr>
+            <a:r>
+              <a:rPr sz="1800" b="1" i="0">
+                <a:solidFill>
+                  <a:srgbClr val="E7C87A"/>
+                </a:solidFill>
+                <a:latin typeface="Helvetica Neue"/>
+              </a:rPr>
+              <a:t>RGPD</a:t>
+            </a:r>
+          </a:p>
+          <a:p>
+            <a:pPr algn="l">
+              <a:spcBef>
+                <a:spcPts val="0"/>
+              </a:spcBef>
+              <a:spcAft>
+                <a:spcPts val="400"/>
+              </a:spcAft>
+            </a:pPr>
+            <a:r>
+              <a:rPr sz="1500" b="0" i="0">
+                <a:solidFill>
+                  <a:srgbClr val="DDD8CE"/>
+                </a:solidFill>
+                <a:latin typeface="Helvetica Neue"/>
+              </a:rPr>
+              <a:t>Bandeau cookies, politique de confidentialité, mentions légales.</a:t>
             </a:r>
           </a:p>
         </p:txBody>
@@ -6844,9 +7000,53 @@
         <p:nvPr/>
       </p:nvGrpSpPr>
       <p:grpSpPr/>
+      <p:sp>
+        <p:nvSpPr>
+          <p:cNvPr id="2" name="Rectangle 1"/>
+          <p:cNvSpPr/>
+          <p:nvPr/>
+        </p:nvSpPr>
+        <p:spPr>
+          <a:xfrm>
+            <a:off x="0" y="0"/>
+            <a:ext cx="12191695" cy="6858000"/>
+          </a:xfrm>
+          <a:prstGeom prst="rect">
+            <a:avLst/>
+          </a:prstGeom>
+          <a:solidFill>
+            <a:srgbClr val="F3EFE8"/>
+          </a:solidFill>
+          <a:ln>
+            <a:noFill/>
+          </a:ln>
+          <a:effectLst/>
+        </p:spPr>
+        <p:style>
+          <a:lnRef idx="1">
+            <a:schemeClr val="accent1"/>
+          </a:lnRef>
+          <a:fillRef idx="3">
+            <a:schemeClr val="accent1"/>
+          </a:fillRef>
+          <a:effectRef idx="2">
+            <a:schemeClr val="accent1"/>
+          </a:effectRef>
+          <a:fontRef idx="minor">
+            <a:schemeClr val="lt1"/>
+          </a:fontRef>
+        </p:style>
+        <p:txBody>
+          <a:bodyPr rtlCol="0" anchor="ctr"/>
+          <a:lstStyle/>
+          <a:p>
+            <a:pPr algn="ctr"/>
+          </a:p>
+        </p:txBody>
+      </p:sp>
       <p:pic>
         <p:nvPicPr>
-          <p:cNvPr id="2" name="Picture 1" descr="c7.jpg"/>
+          <p:cNvPr id="3" name="Picture 2" descr="c8.jpg"/>
           <p:cNvPicPr>
             <a:picLocks noChangeAspect="1"/>
           </p:cNvPicPr>
@@ -6861,7 +7061,7 @@
         <p:spPr>
           <a:xfrm>
             <a:off x="0" y="0"/>
-            <a:ext cx="12191695" cy="6858000"/>
+            <a:ext cx="5120640" cy="6858000"/>
           </a:xfrm>
           <a:prstGeom prst="rect">
             <a:avLst/>
@@ -6870,7 +7070,7 @@
       </p:pic>
       <p:sp>
         <p:nvSpPr>
-          <p:cNvPr id="3" name="TextBox 2"/>
+          <p:cNvPr id="4" name="TextBox 3"/>
           <p:cNvSpPr txBox="1"/>
           <p:nvPr/>
         </p:nvSpPr>
@@ -6901,7 +7101,7 @@
             <a:r>
               <a:rPr sz="1100" b="1" i="0">
                 <a:solidFill>
-                  <a:srgbClr val="E7C87A"/>
+                  <a:srgbClr val="B08D57"/>
                 </a:solidFill>
                 <a:latin typeface="Helvetica Neue"/>
               </a:rPr>
@@ -6912,7 +7112,7 @@
       </p:sp>
       <p:sp>
         <p:nvSpPr>
-          <p:cNvPr id="4" name="TextBox 3"/>
+          <p:cNvPr id="5" name="TextBox 4"/>
           <p:cNvSpPr txBox="1"/>
           <p:nvPr/>
         </p:nvSpPr>
@@ -6943,7 +7143,7 @@
             <a:r>
               <a:rPr sz="1100" b="1" i="0">
                 <a:solidFill>
-                  <a:srgbClr val="C9C4BA"/>
+                  <a:srgbClr val="777777"/>
                 </a:solidFill>
                 <a:latin typeface="Helvetica Neue"/>
               </a:rPr>
@@ -6954,14 +7154,14 @@
       </p:sp>
       <p:sp>
         <p:nvSpPr>
-          <p:cNvPr id="5" name="TextBox 4"/>
+          <p:cNvPr id="6" name="TextBox 5"/>
           <p:cNvSpPr txBox="1"/>
           <p:nvPr/>
         </p:nvSpPr>
         <p:spPr>
           <a:xfrm>
             <a:off x="502920" y="566928"/>
-            <a:ext cx="7315200" cy="274320"/>
+            <a:ext cx="9144000" cy="274320"/>
           </a:xfrm>
           <a:prstGeom prst="rect">
             <a:avLst/>
@@ -6985,25 +7185,25 @@
             <a:r>
               <a:rPr sz="1200" b="1" i="0">
                 <a:solidFill>
-                  <a:srgbClr val="E7C87A"/>
+                  <a:srgbClr val="B08D57"/>
                 </a:solidFill>
                 <a:latin typeface="Helvetica Neue"/>
               </a:rPr>
-              <a:t>LE LIVRABLE · LA BOUTIQUE</a:t>
-            </a:r>
-          </a:p>
-        </p:txBody>
-      </p:sp>
-      <p:sp>
-        <p:nvSpPr>
-          <p:cNvPr id="6" name="TextBox 5"/>
+              <a:t>UX · LA FICHE PRODUIT</a:t>
+            </a:r>
+          </a:p>
+        </p:txBody>
+      </p:sp>
+      <p:sp>
+        <p:nvSpPr>
+          <p:cNvPr id="7" name="TextBox 6"/>
           <p:cNvSpPr txBox="1"/>
           <p:nvPr/>
         </p:nvSpPr>
         <p:spPr>
           <a:xfrm>
-            <a:off x="548640" y="4572000"/>
-            <a:ext cx="9448495" cy="1828800"/>
+            <a:off x="5532120" y="1371600"/>
+            <a:ext cx="5852160" cy="4754880"/>
           </a:xfrm>
           <a:prstGeom prst="rect">
             <a:avLst/>
@@ -7011,7 +7211,7 @@
           <a:noFill/>
         </p:spPr>
         <p:txBody>
-          <a:bodyPr wrap="square" anchor="b">
+          <a:bodyPr wrap="square" anchor="ctr">
             <a:spAutoFit/>
           </a:bodyPr>
           <a:lstStyle/>
@@ -7021,17 +7221,17 @@
                 <a:spcPts val="0"/>
               </a:spcBef>
               <a:spcAft>
-                <a:spcPts val="1000"/>
-              </a:spcAft>
-            </a:pPr>
-            <a:r>
-              <a:rPr sz="3800" b="0" i="0">
-                <a:solidFill>
-                  <a:srgbClr val="FFFFFF"/>
+                <a:spcPts val="1200"/>
+              </a:spcAft>
+            </a:pPr>
+            <a:r>
+              <a:rPr sz="3200" b="0" i="0">
+                <a:solidFill>
+                  <a:srgbClr val="141414"/>
                 </a:solidFill>
                 <a:latin typeface="Georgia"/>
               </a:rPr>
-              <a:t>En ligne. Maintenant.</a:t>
+              <a:t>Pensée pour convertir.</a:t>
             </a:r>
           </a:p>
           <a:p>
@@ -7040,17 +7240,55 @@
                 <a:spcPts val="0"/>
               </a:spcBef>
               <a:spcAft>
-                <a:spcPts val="600"/>
-              </a:spcAft>
-            </a:pPr>
-            <a:r>
-              <a:rPr sz="1700" b="0" i="0">
-                <a:solidFill>
-                  <a:srgbClr val="E8E2D6"/>
+                <a:spcPts val="800"/>
+              </a:spcAft>
+            </a:pPr>
+            <a:r>
+              <a:rPr sz="1600" b="0" i="0">
+                <a:solidFill>
+                  <a:srgbClr val="444444"/>
                 </a:solidFill>
                 <a:latin typeface="Helvetica Neue"/>
               </a:rPr>
-              <a:t>14 pages, panier, paiement Stripe, légal complet — déployée sur jeca-site.vercel.app.</a:t>
+              <a:t>Titre SEO + galerie multi-vues + zoom.</a:t>
+            </a:r>
+          </a:p>
+          <a:p>
+            <a:pPr algn="l">
+              <a:spcBef>
+                <a:spcPts val="0"/>
+              </a:spcBef>
+              <a:spcAft>
+                <a:spcPts val="800"/>
+              </a:spcAft>
+            </a:pPr>
+            <a:r>
+              <a:rPr sz="1600" b="0" i="0">
+                <a:solidFill>
+                  <a:srgbClr val="444444"/>
+                </a:solidFill>
+                <a:latin typeface="Helvetica Neue"/>
+              </a:rPr>
+              <a:t>Prix, réassurance, CTA sans scroll.</a:t>
+            </a:r>
+          </a:p>
+          <a:p>
+            <a:pPr algn="l">
+              <a:spcBef>
+                <a:spcPts val="0"/>
+              </a:spcBef>
+              <a:spcAft>
+                <a:spcPts val="800"/>
+              </a:spcAft>
+            </a:pPr>
+            <a:r>
+              <a:rPr sz="1600" b="0" i="0">
+                <a:solidFill>
+                  <a:srgbClr val="444444"/>
+                </a:solidFill>
+                <a:latin typeface="Helvetica Neue"/>
+              </a:rPr>
+              <a:t>Avis 4,9/5 et « vous aimerez aussi ».</a:t>
             </a:r>
           </a:p>
         </p:txBody>
@@ -7117,30 +7355,50 @@
           </a:p>
         </p:txBody>
       </p:sp>
-      <p:pic>
-        <p:nvPicPr>
-          <p:cNvPr id="3" name="Picture 2" descr="c8.jpg"/>
-          <p:cNvPicPr>
-            <a:picLocks noChangeAspect="1"/>
-          </p:cNvPicPr>
-          <p:nvPr/>
-        </p:nvPicPr>
-        <p:blipFill>
-          <a:blip r:embed="rId2"/>
-          <a:stretch>
-            <a:fillRect/>
-          </a:stretch>
-        </p:blipFill>
-        <p:spPr>
-          <a:xfrm>
-            <a:off x="0" y="0"/>
-            <a:ext cx="5120640" cy="6858000"/>
-          </a:xfrm>
-          <a:prstGeom prst="rect">
-            <a:avLst/>
-          </a:prstGeom>
-        </p:spPr>
-      </p:pic>
+      <p:sp>
+        <p:nvSpPr>
+          <p:cNvPr id="3" name="Rectangle 2"/>
+          <p:cNvSpPr/>
+          <p:nvPr/>
+        </p:nvSpPr>
+        <p:spPr>
+          <a:xfrm>
+            <a:off x="502920" y="1417320"/>
+            <a:ext cx="822960" cy="38100"/>
+          </a:xfrm>
+          <a:prstGeom prst="rect">
+            <a:avLst/>
+          </a:prstGeom>
+          <a:solidFill>
+            <a:srgbClr val="B08D57"/>
+          </a:solidFill>
+          <a:ln>
+            <a:noFill/>
+          </a:ln>
+          <a:effectLst/>
+        </p:spPr>
+        <p:style>
+          <a:lnRef idx="1">
+            <a:schemeClr val="accent1"/>
+          </a:lnRef>
+          <a:fillRef idx="3">
+            <a:schemeClr val="accent1"/>
+          </a:fillRef>
+          <a:effectRef idx="2">
+            <a:schemeClr val="accent1"/>
+          </a:effectRef>
+          <a:fontRef idx="minor">
+            <a:schemeClr val="lt1"/>
+          </a:fontRef>
+        </p:style>
+        <p:txBody>
+          <a:bodyPr rtlCol="0" anchor="ctr"/>
+          <a:lstStyle/>
+          <a:p>
+            <a:pPr algn="ctr"/>
+          </a:p>
+        </p:txBody>
+      </p:sp>
       <p:sp>
         <p:nvSpPr>
           <p:cNvPr id="4" name="TextBox 3"/>
@@ -7234,7 +7492,7 @@
         <p:spPr>
           <a:xfrm>
             <a:off x="502920" y="566928"/>
-            <a:ext cx="7315200" cy="274320"/>
+            <a:ext cx="9144000" cy="274320"/>
           </a:xfrm>
           <a:prstGeom prst="rect">
             <a:avLst/>
@@ -7262,7 +7520,7 @@
                 </a:solidFill>
                 <a:latin typeface="Helvetica Neue"/>
               </a:rPr>
-              <a:t>UX &amp; SEO</a:t>
+              <a:t>SEO &amp; CALENDRIER ÉDITORIAL</a:t>
             </a:r>
           </a:p>
         </p:txBody>
@@ -7275,8 +7533,8 @@
         </p:nvSpPr>
         <p:spPr>
           <a:xfrm>
-            <a:off x="5532120" y="1371600"/>
-            <a:ext cx="5852160" cy="4754880"/>
+            <a:off x="502920" y="1737360"/>
+            <a:ext cx="10911535" cy="914400"/>
           </a:xfrm>
           <a:prstGeom prst="rect">
             <a:avLst/>
@@ -7284,7 +7542,7 @@
           <a:noFill/>
         </p:spPr>
         <p:txBody>
-          <a:bodyPr wrap="square" anchor="ctr">
+          <a:bodyPr wrap="square" anchor="t">
             <a:spAutoFit/>
           </a:bodyPr>
           <a:lstStyle/>
@@ -7294,74 +7552,192 @@
                 <a:spcPts val="0"/>
               </a:spcBef>
               <a:spcAft>
-                <a:spcPts val="1200"/>
-              </a:spcAft>
-            </a:pPr>
-            <a:r>
-              <a:rPr sz="3300" b="0" i="0">
+                <a:spcPts val="600"/>
+              </a:spcAft>
+            </a:pPr>
+            <a:r>
+              <a:rPr sz="3400" b="0" i="0">
                 <a:solidFill>
                   <a:srgbClr val="141414"/>
                 </a:solidFill>
                 <a:latin typeface="Georgia"/>
               </a:rPr>
-              <a:t>Une fiche pensée pour convertir.</a:t>
-            </a:r>
-          </a:p>
+              <a:t>Être trouvé, gratuitement.</a:t>
+            </a:r>
+          </a:p>
+        </p:txBody>
+      </p:sp>
+      <p:sp>
+        <p:nvSpPr>
+          <p:cNvPr id="8" name="TextBox 7"/>
+          <p:cNvSpPr txBox="1"/>
+          <p:nvPr/>
+        </p:nvSpPr>
+        <p:spPr>
+          <a:xfrm>
+            <a:off x="502920" y="2743200"/>
+            <a:ext cx="10911535" cy="3657600"/>
+          </a:xfrm>
+          <a:prstGeom prst="rect">
+            <a:avLst/>
+          </a:prstGeom>
+          <a:noFill/>
+        </p:spPr>
+        <p:txBody>
+          <a:bodyPr wrap="square" anchor="t">
+            <a:spAutoFit/>
+          </a:bodyPr>
+          <a:lstStyle/>
           <a:p>
             <a:pPr algn="l">
               <a:spcBef>
-                <a:spcPts val="0"/>
-              </a:spcBef>
-              <a:spcAft>
                 <a:spcPts val="800"/>
-              </a:spcAft>
-            </a:pPr>
-            <a:r>
-              <a:rPr sz="1600" b="0" i="0">
+              </a:spcBef>
+              <a:spcAft>
+                <a:spcPts val="100"/>
+              </a:spcAft>
+            </a:pPr>
+            <a:r>
+              <a:rPr sz="1800" b="1" i="0">
+                <a:solidFill>
+                  <a:srgbClr val="B08D57"/>
+                </a:solidFill>
+                <a:latin typeface="Helvetica Neue"/>
+              </a:rPr>
+              <a:t>Mots-clés</a:t>
+            </a:r>
+          </a:p>
+          <a:p>
+            <a:pPr algn="l">
+              <a:spcBef>
+                <a:spcPts val="0"/>
+              </a:spcBef>
+              <a:spcAft>
+                <a:spcPts val="400"/>
+              </a:spcAft>
+            </a:pPr>
+            <a:r>
+              <a:rPr sz="1500" b="0" i="0">
                 <a:solidFill>
                   <a:srgbClr val="444444"/>
                 </a:solidFill>
                 <a:latin typeface="Helvetica Neue"/>
               </a:rPr>
-              <a:t>Titre SEO, galerie multi-vues, zoom.</a:t>
+              <a:t>« bracelet GPS enfant », « bijou géolocalisation enfant ».</a:t>
             </a:r>
           </a:p>
           <a:p>
             <a:pPr algn="l">
               <a:spcBef>
-                <a:spcPts val="0"/>
-              </a:spcBef>
-              <a:spcAft>
                 <a:spcPts val="800"/>
-              </a:spcAft>
-            </a:pPr>
-            <a:r>
-              <a:rPr sz="1600" b="0" i="0">
+              </a:spcBef>
+              <a:spcAft>
+                <a:spcPts val="100"/>
+              </a:spcAft>
+            </a:pPr>
+            <a:r>
+              <a:rPr sz="1800" b="1" i="0">
+                <a:solidFill>
+                  <a:srgbClr val="B08D57"/>
+                </a:solidFill>
+                <a:latin typeface="Helvetica Neue"/>
+              </a:rPr>
+              <a:t>On-page</a:t>
+            </a:r>
+          </a:p>
+          <a:p>
+            <a:pPr algn="l">
+              <a:spcBef>
+                <a:spcPts val="0"/>
+              </a:spcBef>
+              <a:spcAft>
+                <a:spcPts val="400"/>
+              </a:spcAft>
+            </a:pPr>
+            <a:r>
+              <a:rPr sz="1500" b="0" i="0">
                 <a:solidFill>
                   <a:srgbClr val="444444"/>
                 </a:solidFill>
                 <a:latin typeface="Helvetica Neue"/>
               </a:rPr>
-              <a:t>Prix, réassurance, CTA sans scroll.</a:t>
+              <a:t>balises meta title/description, titres Hn, contenu riche.</a:t>
             </a:r>
           </a:p>
           <a:p>
             <a:pPr algn="l">
               <a:spcBef>
-                <a:spcPts val="0"/>
-              </a:spcBef>
-              <a:spcAft>
                 <a:spcPts val="800"/>
-              </a:spcAft>
-            </a:pPr>
-            <a:r>
-              <a:rPr sz="1600" b="0" i="0">
+              </a:spcBef>
+              <a:spcAft>
+                <a:spcPts val="100"/>
+              </a:spcAft>
+            </a:pPr>
+            <a:r>
+              <a:rPr sz="1800" b="1" i="0">
+                <a:solidFill>
+                  <a:srgbClr val="B08D57"/>
+                </a:solidFill>
+                <a:latin typeface="Helvetica Neue"/>
+              </a:rPr>
+              <a:t>Contenu</a:t>
+            </a:r>
+          </a:p>
+          <a:p>
+            <a:pPr algn="l">
+              <a:spcBef>
+                <a:spcPts val="0"/>
+              </a:spcBef>
+              <a:spcAft>
+                <a:spcPts val="400"/>
+              </a:spcAft>
+            </a:pPr>
+            <a:r>
+              <a:rPr sz="1500" b="0" i="0">
                 <a:solidFill>
                   <a:srgbClr val="444444"/>
                 </a:solidFill>
                 <a:latin typeface="Helvetica Neue"/>
               </a:rPr>
-              <a:t>Avis 4,9/5 + « vous aimerez aussi ».</a:t>
+              <a:t>blog parentalité &amp; sécurité — 1 article / semaine.</a:t>
+            </a:r>
+          </a:p>
+          <a:p>
+            <a:pPr algn="l">
+              <a:spcBef>
+                <a:spcPts val="800"/>
+              </a:spcBef>
+              <a:spcAft>
+                <a:spcPts val="100"/>
+              </a:spcAft>
+            </a:pPr>
+            <a:r>
+              <a:rPr sz="1800" b="1" i="0">
+                <a:solidFill>
+                  <a:srgbClr val="B08D57"/>
+                </a:solidFill>
+                <a:latin typeface="Helvetica Neue"/>
+              </a:rPr>
+              <a:t>Calendrier éditorial</a:t>
+            </a:r>
+          </a:p>
+          <a:p>
+            <a:pPr algn="l">
+              <a:spcBef>
+                <a:spcPts val="0"/>
+              </a:spcBef>
+              <a:spcAft>
+                <a:spcPts val="400"/>
+              </a:spcAft>
+            </a:pPr>
+            <a:r>
+              <a:rPr sz="1500" b="0" i="0">
+                <a:solidFill>
+                  <a:srgbClr val="444444"/>
+                </a:solidFill>
+                <a:latin typeface="Helvetica Neue"/>
+              </a:rPr>
+              <a:t>posts Insta/TikTok, temps forts : rentrée, Noël, fête des mères.</a:t>
             </a:r>
           </a:p>
         </p:txBody>
@@ -7565,7 +7941,7 @@
         <p:spPr>
           <a:xfrm>
             <a:off x="502920" y="566928"/>
-            <a:ext cx="7315200" cy="274320"/>
+            <a:ext cx="9144000" cy="274320"/>
           </a:xfrm>
           <a:prstGeom prst="rect">
             <a:avLst/>
@@ -7593,7 +7969,7 @@
                 </a:solidFill>
                 <a:latin typeface="Helvetica Neue"/>
               </a:rPr>
-              <a:t>LE CŒUR DU PROJET</a:t>
+              <a:t>LES IA UTILISÉES</a:t>
             </a:r>
           </a:p>
         </p:txBody>
@@ -7606,8 +7982,8 @@
         </p:nvSpPr>
         <p:spPr>
           <a:xfrm>
-            <a:off x="502920" y="1783080"/>
-            <a:ext cx="10911535" cy="4023360"/>
+            <a:off x="502920" y="1737360"/>
+            <a:ext cx="10911535" cy="914400"/>
           </a:xfrm>
           <a:prstGeom prst="rect">
             <a:avLst/>
@@ -7625,11 +8001,11 @@
                 <a:spcPts val="0"/>
               </a:spcBef>
               <a:spcAft>
-                <a:spcPts val="1400"/>
-              </a:spcAft>
-            </a:pPr>
-            <a:r>
-              <a:rPr sz="4000" b="0" i="0">
+                <a:spcPts val="600"/>
+              </a:spcAft>
+            </a:pPr>
+            <a:r>
+              <a:rPr sz="3400" b="0" i="0">
                 <a:solidFill>
                   <a:srgbClr val="FFFFFF"/>
                 </a:solidFill>
@@ -7638,23 +8014,179 @@
               <a:t>Construit de A à Z avec l'IA.</a:t>
             </a:r>
           </a:p>
+        </p:txBody>
+      </p:sp>
+      <p:sp>
+        <p:nvSpPr>
+          <p:cNvPr id="8" name="TextBox 7"/>
+          <p:cNvSpPr txBox="1"/>
+          <p:nvPr/>
+        </p:nvSpPr>
+        <p:spPr>
+          <a:xfrm>
+            <a:off x="502920" y="2743200"/>
+            <a:ext cx="10911535" cy="3657600"/>
+          </a:xfrm>
+          <a:prstGeom prst="rect">
+            <a:avLst/>
+          </a:prstGeom>
+          <a:noFill/>
+        </p:spPr>
+        <p:txBody>
+          <a:bodyPr wrap="square" anchor="t">
+            <a:spAutoFit/>
+          </a:bodyPr>
+          <a:lstStyle/>
           <a:p>
             <a:pPr algn="l">
               <a:spcBef>
-                <a:spcPts val="0"/>
-              </a:spcBef>
-              <a:spcAft>
-                <a:spcPts val="600"/>
-              </a:spcAft>
-            </a:pPr>
-            <a:r>
-              <a:rPr sz="1800" b="0" i="0">
-                <a:solidFill>
-                  <a:srgbClr val="C9C4BA"/>
+                <a:spcPts val="800"/>
+              </a:spcBef>
+              <a:spcAft>
+                <a:spcPts val="100"/>
+              </a:spcAft>
+            </a:pPr>
+            <a:r>
+              <a:rPr sz="1800" b="1" i="0">
+                <a:solidFill>
+                  <a:srgbClr val="E7C87A"/>
                 </a:solidFill>
                 <a:latin typeface="Helvetica Neue"/>
               </a:rPr>
-              <a:t>Claude : le site et le code. Canva IA : logo, visuels, film publicitaire. ChatGPT : fiches &amp; SEO. Python : l'automatisation. L'IA accélère, l'humain décide.</a:t>
+              <a:t>Claude (Anthropic)</a:t>
+            </a:r>
+          </a:p>
+          <a:p>
+            <a:pPr algn="l">
+              <a:spcBef>
+                <a:spcPts val="0"/>
+              </a:spcBef>
+              <a:spcAft>
+                <a:spcPts val="400"/>
+              </a:spcAft>
+            </a:pPr>
+            <a:r>
+              <a:rPr sz="1500" b="0" i="0">
+                <a:solidFill>
+                  <a:srgbClr val="DDD8CE"/>
+                </a:solidFill>
+                <a:latin typeface="Helvetica Neue"/>
+              </a:rPr>
+              <a:t>tout le site, le code, le panier, l'intégration Stripe, le déploiement.</a:t>
+            </a:r>
+          </a:p>
+          <a:p>
+            <a:pPr algn="l">
+              <a:spcBef>
+                <a:spcPts val="800"/>
+              </a:spcBef>
+              <a:spcAft>
+                <a:spcPts val="100"/>
+              </a:spcAft>
+            </a:pPr>
+            <a:r>
+              <a:rPr sz="1800" b="1" i="0">
+                <a:solidFill>
+                  <a:srgbClr val="E7C87A"/>
+                </a:solidFill>
+                <a:latin typeface="Helvetica Neue"/>
+              </a:rPr>
+              <a:t>Canva IA</a:t>
+            </a:r>
+          </a:p>
+          <a:p>
+            <a:pPr algn="l">
+              <a:spcBef>
+                <a:spcPts val="0"/>
+              </a:spcBef>
+              <a:spcAft>
+                <a:spcPts val="400"/>
+              </a:spcAft>
+            </a:pPr>
+            <a:r>
+              <a:rPr sz="1500" b="0" i="0">
+                <a:solidFill>
+                  <a:srgbClr val="DDD8CE"/>
+                </a:solidFill>
+                <a:latin typeface="Helvetica Neue"/>
+              </a:rPr>
+              <a:t>le logo, les visuels produit (or &amp; argent) et le film publicitaire.</a:t>
+            </a:r>
+          </a:p>
+          <a:p>
+            <a:pPr algn="l">
+              <a:spcBef>
+                <a:spcPts val="800"/>
+              </a:spcBef>
+              <a:spcAft>
+                <a:spcPts val="100"/>
+              </a:spcAft>
+            </a:pPr>
+            <a:r>
+              <a:rPr sz="1800" b="1" i="0">
+                <a:solidFill>
+                  <a:srgbClr val="E7C87A"/>
+                </a:solidFill>
+                <a:latin typeface="Helvetica Neue"/>
+              </a:rPr>
+              <a:t>ChatGPT</a:t>
+            </a:r>
+          </a:p>
+          <a:p>
+            <a:pPr algn="l">
+              <a:spcBef>
+                <a:spcPts val="0"/>
+              </a:spcBef>
+              <a:spcAft>
+                <a:spcPts val="400"/>
+              </a:spcAft>
+            </a:pPr>
+            <a:r>
+              <a:rPr sz="1500" b="0" i="0">
+                <a:solidFill>
+                  <a:srgbClr val="DDD8CE"/>
+                </a:solidFill>
+                <a:latin typeface="Helvetica Neue"/>
+              </a:rPr>
+              <a:t>fiches produit, textes SEO, balises meta, CGV, personas.</a:t>
+            </a:r>
+          </a:p>
+          <a:p>
+            <a:pPr algn="l">
+              <a:spcBef>
+                <a:spcPts val="800"/>
+              </a:spcBef>
+              <a:spcAft>
+                <a:spcPts val="100"/>
+              </a:spcAft>
+            </a:pPr>
+            <a:r>
+              <a:rPr sz="1800" b="1" i="0">
+                <a:solidFill>
+                  <a:srgbClr val="E7C87A"/>
+                </a:solidFill>
+                <a:latin typeface="Helvetica Neue"/>
+              </a:rPr>
+              <a:t>Python + Perplexity</a:t>
+            </a:r>
+          </a:p>
+          <a:p>
+            <a:pPr algn="l">
+              <a:spcBef>
+                <a:spcPts val="0"/>
+              </a:spcBef>
+              <a:spcAft>
+                <a:spcPts val="400"/>
+              </a:spcAft>
+            </a:pPr>
+            <a:r>
+              <a:rPr sz="1500" b="0" i="0">
+                <a:solidFill>
+                  <a:srgbClr val="DDD8CE"/>
+                </a:solidFill>
+                <a:latin typeface="Helvetica Neue"/>
+              </a:rPr>
+              <a:t>automatisation des supports &amp; veille marché. → vitesse ×10, zéro budget agence.</a:t>
             </a:r>
           </a:p>
         </p:txBody>
@@ -7692,7 +8224,7 @@
             <a:avLst/>
           </a:prstGeom>
           <a:solidFill>
-            <a:srgbClr val="F3EFE8"/>
+            <a:srgbClr val="1F3A5F"/>
           </a:solidFill>
           <a:ln>
             <a:noFill/>
@@ -7721,30 +8253,50 @@
           </a:p>
         </p:txBody>
       </p:sp>
-      <p:pic>
-        <p:nvPicPr>
-          <p:cNvPr id="3" name="Picture 2" descr="c9.jpg"/>
-          <p:cNvPicPr>
-            <a:picLocks noChangeAspect="1"/>
-          </p:cNvPicPr>
-          <p:nvPr/>
-        </p:nvPicPr>
-        <p:blipFill>
-          <a:blip r:embed="rId2"/>
-          <a:stretch>
-            <a:fillRect/>
-          </a:stretch>
-        </p:blipFill>
-        <p:spPr>
-          <a:xfrm>
-            <a:off x="7071055" y="0"/>
-            <a:ext cx="5120640" cy="6858000"/>
-          </a:xfrm>
-          <a:prstGeom prst="rect">
-            <a:avLst/>
-          </a:prstGeom>
-        </p:spPr>
-      </p:pic>
+      <p:sp>
+        <p:nvSpPr>
+          <p:cNvPr id="3" name="Rectangle 2"/>
+          <p:cNvSpPr/>
+          <p:nvPr/>
+        </p:nvSpPr>
+        <p:spPr>
+          <a:xfrm>
+            <a:off x="502920" y="1417320"/>
+            <a:ext cx="822960" cy="38100"/>
+          </a:xfrm>
+          <a:prstGeom prst="rect">
+            <a:avLst/>
+          </a:prstGeom>
+          <a:solidFill>
+            <a:srgbClr val="E7C87A"/>
+          </a:solidFill>
+          <a:ln>
+            <a:noFill/>
+          </a:ln>
+          <a:effectLst/>
+        </p:spPr>
+        <p:style>
+          <a:lnRef idx="1">
+            <a:schemeClr val="accent1"/>
+          </a:lnRef>
+          <a:fillRef idx="3">
+            <a:schemeClr val="accent1"/>
+          </a:fillRef>
+          <a:effectRef idx="2">
+            <a:schemeClr val="accent1"/>
+          </a:effectRef>
+          <a:fontRef idx="minor">
+            <a:schemeClr val="lt1"/>
+          </a:fontRef>
+        </p:style>
+        <p:txBody>
+          <a:bodyPr rtlCol="0" anchor="ctr"/>
+          <a:lstStyle/>
+          <a:p>
+            <a:pPr algn="ctr"/>
+          </a:p>
+        </p:txBody>
+      </p:sp>
       <p:sp>
         <p:nvSpPr>
           <p:cNvPr id="4" name="TextBox 3"/>
@@ -7778,7 +8330,7 @@
             <a:r>
               <a:rPr sz="1100" b="1" i="0">
                 <a:solidFill>
-                  <a:srgbClr val="B08D57"/>
+                  <a:srgbClr val="E7C87A"/>
                 </a:solidFill>
                 <a:latin typeface="Helvetica Neue"/>
               </a:rPr>
@@ -7820,7 +8372,7 @@
             <a:r>
               <a:rPr sz="1100" b="1" i="0">
                 <a:solidFill>
-                  <a:srgbClr val="777777"/>
+                  <a:srgbClr val="C9C4BA"/>
                 </a:solidFill>
                 <a:latin typeface="Helvetica Neue"/>
               </a:rPr>
@@ -7838,7 +8390,7 @@
         <p:spPr>
           <a:xfrm>
             <a:off x="502920" y="566928"/>
-            <a:ext cx="7315200" cy="274320"/>
+            <a:ext cx="9144000" cy="274320"/>
           </a:xfrm>
           <a:prstGeom prst="rect">
             <a:avLst/>
@@ -7862,11 +8414,11 @@
             <a:r>
               <a:rPr sz="1200" b="1" i="0">
                 <a:solidFill>
-                  <a:srgbClr val="B08D57"/>
+                  <a:srgbClr val="E7C87A"/>
                 </a:solidFill>
                 <a:latin typeface="Helvetica Neue"/>
               </a:rPr>
-              <a:t>BUSINESS MODEL</a:t>
+              <a:t>LA CONCURRENCE</a:t>
             </a:r>
           </a:p>
         </p:txBody>
@@ -7879,8 +8431,8 @@
         </p:nvSpPr>
         <p:spPr>
           <a:xfrm>
-            <a:off x="640080" y="1371600"/>
-            <a:ext cx="5852160" cy="4754880"/>
+            <a:off x="502920" y="1783080"/>
+            <a:ext cx="10911535" cy="4023360"/>
           </a:xfrm>
           <a:prstGeom prst="rect">
             <a:avLst/>
@@ -7888,7 +8440,7 @@
           <a:noFill/>
         </p:spPr>
         <p:txBody>
-          <a:bodyPr wrap="square" anchor="ctr">
+          <a:bodyPr wrap="square" anchor="t">
             <a:spAutoFit/>
           </a:bodyPr>
           <a:lstStyle/>
@@ -7898,17 +8450,17 @@
                 <a:spcPts val="0"/>
               </a:spcBef>
               <a:spcAft>
-                <a:spcPts val="1200"/>
-              </a:spcAft>
-            </a:pPr>
-            <a:r>
-              <a:rPr sz="3300" b="0" i="0">
-                <a:solidFill>
-                  <a:srgbClr val="141414"/>
+                <a:spcPts val="1400"/>
+              </a:spcAft>
+            </a:pPr>
+            <a:r>
+              <a:rPr sz="4000" b="0" i="0">
+                <a:solidFill>
+                  <a:srgbClr val="FFFFFF"/>
                 </a:solidFill>
                 <a:latin typeface="Georgia"/>
               </a:rPr>
-              <a:t>Vente + abonnement.</a:t>
+              <a:t>Personne n'occupe notre place.</a:t>
             </a:r>
           </a:p>
           <a:p>
@@ -7917,55 +8469,17 @@
                 <a:spcPts val="0"/>
               </a:spcBef>
               <a:spcAft>
-                <a:spcPts val="800"/>
-              </a:spcAft>
-            </a:pPr>
-            <a:r>
-              <a:rPr sz="1600" b="0" i="0">
-                <a:solidFill>
-                  <a:srgbClr val="444444"/>
+                <a:spcPts val="600"/>
+              </a:spcAft>
+            </a:pPr>
+            <a:r>
+              <a:rPr sz="1800" b="0" i="0">
+                <a:solidFill>
+                  <a:srgbClr val="DDD8CE"/>
                 </a:solidFill>
                 <a:latin typeface="Helvetica Neue"/>
               </a:rPr>
-              <a:t>Le bijou : un revenu immédiat (marge ~58 %).</a:t>
-            </a:r>
-          </a:p>
-          <a:p>
-            <a:pPr algn="l">
-              <a:spcBef>
-                <a:spcPts val="0"/>
-              </a:spcBef>
-              <a:spcAft>
-                <a:spcPts val="800"/>
-              </a:spcAft>
-            </a:pPr>
-            <a:r>
-              <a:rPr sz="1600" b="0" i="0">
-                <a:solidFill>
-                  <a:srgbClr val="444444"/>
-                </a:solidFill>
-                <a:latin typeface="Helvetica Neue"/>
-              </a:rPr>
-              <a:t>L'abonnement 6,99–9,99 €/mois : récurrent.</a:t>
-            </a:r>
-          </a:p>
-          <a:p>
-            <a:pPr algn="l">
-              <a:spcBef>
-                <a:spcPts val="0"/>
-              </a:spcBef>
-              <a:spcAft>
-                <a:spcPts val="800"/>
-              </a:spcAft>
-            </a:pPr>
-            <a:r>
-              <a:rPr sz="1600" b="0" i="0">
-                <a:solidFill>
-                  <a:srgbClr val="444444"/>
-                </a:solidFill>
-                <a:latin typeface="Helvetica Neue"/>
-              </a:rPr>
-              <a:t>Sans abonnement, le bijou perd sa fonction → rétention élevée.</a:t>
+              <a:t>Weenect : une balise qu'on oublie. Xplora : une montre encombrante. AngelSense : un boîtier médicalisé. JECA : le seul vrai bijou + GPS + données en France.</a:t>
             </a:r>
           </a:p>
         </p:txBody>
@@ -8125,7 +8639,7 @@
         <p:spPr>
           <a:xfrm>
             <a:off x="502920" y="566928"/>
-            <a:ext cx="7315200" cy="274320"/>
+            <a:ext cx="9144000" cy="274320"/>
           </a:xfrm>
           <a:prstGeom prst="rect">
             <a:avLst/>
@@ -8153,7 +8667,7 @@
                 </a:solidFill>
                 <a:latin typeface="Helvetica Neue"/>
               </a:rPr>
-              <a:t>DATA · RÉSULTATS</a:t>
+              <a:t>DATA · KPI &amp; TABLEAU DE BORD</a:t>
             </a:r>
           </a:p>
         </p:txBody>
@@ -8239,7 +8753,7 @@
                 </a:solidFill>
                 <a:latin typeface="Georgia"/>
               </a:rPr>
-              <a:t>Rentable dès l'année 1</a:t>
+              <a:t>Les indicateurs que nous suivons — et pourquoi</a:t>
             </a:r>
           </a:p>
         </p:txBody>
@@ -8252,8 +8766,8 @@
         </p:nvSpPr>
         <p:spPr>
           <a:xfrm>
-            <a:off x="502920" y="3200400"/>
-            <a:ext cx="2522143" cy="2011680"/>
+            <a:off x="502920" y="3017520"/>
+            <a:ext cx="2522143" cy="2194560"/>
           </a:xfrm>
           <a:prstGeom prst="rect">
             <a:avLst/>
@@ -8271,36 +8785,36 @@
                 <a:spcPts val="0"/>
               </a:spcBef>
               <a:spcAft>
+                <a:spcPts val="800"/>
+              </a:spcAft>
+            </a:pPr>
+            <a:r>
+              <a:rPr sz="3000" b="1" i="0">
+                <a:solidFill>
+                  <a:srgbClr val="E7C87A"/>
+                </a:solidFill>
+                <a:latin typeface="Georgia"/>
+              </a:rPr>
+              <a:t>Taux de conversion</a:t>
+            </a:r>
+          </a:p>
+          <a:p>
+            <a:pPr algn="ctr">
+              <a:spcBef>
+                <a:spcPts val="0"/>
+              </a:spcBef>
+              <a:spcAft>
                 <a:spcPts val="600"/>
               </a:spcAft>
             </a:pPr>
             <a:r>
-              <a:rPr sz="5000" b="1" i="0">
-                <a:solidFill>
-                  <a:srgbClr val="E7C87A"/>
-                </a:solidFill>
-                <a:latin typeface="Georgia"/>
-              </a:rPr>
-              <a:t>762 k€</a:t>
-            </a:r>
-          </a:p>
-          <a:p>
-            <a:pPr algn="ctr">
-              <a:spcBef>
-                <a:spcPts val="0"/>
-              </a:spcBef>
-              <a:spcAft>
-                <a:spcPts val="600"/>
-              </a:spcAft>
-            </a:pPr>
-            <a:r>
-              <a:rPr sz="1400" b="0" i="0">
+              <a:rPr sz="1350" b="0" i="0">
                 <a:solidFill>
                   <a:srgbClr val="CFD6E0"/>
                 </a:solidFill>
                 <a:latin typeface="Helvetica Neue"/>
               </a:rPr>
-              <a:t>CA année 1</a:t>
+              <a:t>santé de la boutique</a:t>
             </a:r>
           </a:p>
         </p:txBody>
@@ -8313,8 +8827,8 @@
         </p:nvSpPr>
         <p:spPr>
           <a:xfrm>
-            <a:off x="3390823" y="3200400"/>
-            <a:ext cx="2522143" cy="2011680"/>
+            <a:off x="3390823" y="3017520"/>
+            <a:ext cx="2522143" cy="2194560"/>
           </a:xfrm>
           <a:prstGeom prst="rect">
             <a:avLst/>
@@ -8332,36 +8846,36 @@
                 <a:spcPts val="0"/>
               </a:spcBef>
               <a:spcAft>
+                <a:spcPts val="800"/>
+              </a:spcAft>
+            </a:pPr>
+            <a:r>
+              <a:rPr sz="3000" b="1" i="0">
+                <a:solidFill>
+                  <a:srgbClr val="E7C87A"/>
+                </a:solidFill>
+                <a:latin typeface="Georgia"/>
+              </a:rPr>
+              <a:t>CAC</a:t>
+            </a:r>
+          </a:p>
+          <a:p>
+            <a:pPr algn="ctr">
+              <a:spcBef>
+                <a:spcPts val="0"/>
+              </a:spcBef>
+              <a:spcAft>
                 <a:spcPts val="600"/>
               </a:spcAft>
             </a:pPr>
             <a:r>
-              <a:rPr sz="5000" b="1" i="0">
-                <a:solidFill>
-                  <a:srgbClr val="E7C87A"/>
-                </a:solidFill>
-                <a:latin typeface="Georgia"/>
-              </a:rPr>
-              <a:t>6 000</a:t>
-            </a:r>
-          </a:p>
-          <a:p>
-            <a:pPr algn="ctr">
-              <a:spcBef>
-                <a:spcPts val="0"/>
-              </a:spcBef>
-              <a:spcAft>
-                <a:spcPts val="600"/>
-              </a:spcAft>
-            </a:pPr>
-            <a:r>
-              <a:rPr sz="1400" b="0" i="0">
+              <a:rPr sz="1350" b="0" i="0">
                 <a:solidFill>
                   <a:srgbClr val="CFD6E0"/>
                 </a:solidFill>
                 <a:latin typeface="Helvetica Neue"/>
               </a:rPr>
-              <a:t>bijoux vendus</a:t>
+              <a:t>rentabilité de l'acquisition</a:t>
             </a:r>
           </a:p>
         </p:txBody>
@@ -8374,8 +8888,8 @@
         </p:nvSpPr>
         <p:spPr>
           <a:xfrm>
-            <a:off x="6278727" y="3200400"/>
-            <a:ext cx="2522143" cy="2011680"/>
+            <a:off x="6278727" y="3017520"/>
+            <a:ext cx="2522143" cy="2194560"/>
           </a:xfrm>
           <a:prstGeom prst="rect">
             <a:avLst/>
@@ -8393,36 +8907,36 @@
                 <a:spcPts val="0"/>
               </a:spcBef>
               <a:spcAft>
+                <a:spcPts val="800"/>
+              </a:spcAft>
+            </a:pPr>
+            <a:r>
+              <a:rPr sz="3000" b="1" i="0">
+                <a:solidFill>
+                  <a:srgbClr val="E7C87A"/>
+                </a:solidFill>
+                <a:latin typeface="Georgia"/>
+              </a:rPr>
+              <a:t>Rétention abonnés</a:t>
+            </a:r>
+          </a:p>
+          <a:p>
+            <a:pPr algn="ctr">
+              <a:spcBef>
+                <a:spcPts val="0"/>
+              </a:spcBef>
+              <a:spcAft>
                 <a:spcPts val="600"/>
               </a:spcAft>
             </a:pPr>
             <a:r>
-              <a:rPr sz="5000" b="1" i="0">
-                <a:solidFill>
-                  <a:srgbClr val="E7C87A"/>
-                </a:solidFill>
-                <a:latin typeface="Georgia"/>
-              </a:rPr>
-              <a:t>4 200</a:t>
-            </a:r>
-          </a:p>
-          <a:p>
-            <a:pPr algn="ctr">
-              <a:spcBef>
-                <a:spcPts val="0"/>
-              </a:spcBef>
-              <a:spcAft>
-                <a:spcPts val="600"/>
-              </a:spcAft>
-            </a:pPr>
-            <a:r>
-              <a:rPr sz="1400" b="0" i="0">
+              <a:rPr sz="1350" b="0" i="0">
                 <a:solidFill>
                   <a:srgbClr val="CFD6E0"/>
                 </a:solidFill>
                 <a:latin typeface="Helvetica Neue"/>
               </a:rPr>
-              <a:t>abonnés actifs</a:t>
+              <a:t>cœur du modèle récurrent</a:t>
             </a:r>
           </a:p>
         </p:txBody>
@@ -8435,8 +8949,8 @@
         </p:nvSpPr>
         <p:spPr>
           <a:xfrm>
-            <a:off x="9166631" y="3200400"/>
-            <a:ext cx="2522143" cy="2011680"/>
+            <a:off x="9166631" y="3017520"/>
+            <a:ext cx="2522143" cy="2194560"/>
           </a:xfrm>
           <a:prstGeom prst="rect">
             <a:avLst/>
@@ -8454,21 +8968,63 @@
                 <a:spcPts val="0"/>
               </a:spcBef>
               <a:spcAft>
+                <a:spcPts val="800"/>
+              </a:spcAft>
+            </a:pPr>
+            <a:r>
+              <a:rPr sz="3000" b="1" i="0">
+                <a:solidFill>
+                  <a:srgbClr val="E7C87A"/>
+                </a:solidFill>
+                <a:latin typeface="Georgia"/>
+              </a:rPr>
+              <a:t>LTV / panier moyen</a:t>
+            </a:r>
+          </a:p>
+          <a:p>
+            <a:pPr algn="ctr">
+              <a:spcBef>
+                <a:spcPts val="0"/>
+              </a:spcBef>
+              <a:spcAft>
                 <a:spcPts val="600"/>
               </a:spcAft>
             </a:pPr>
             <a:r>
-              <a:rPr sz="5000" b="1" i="0">
-                <a:solidFill>
-                  <a:srgbClr val="E7C87A"/>
-                </a:solidFill>
-                <a:latin typeface="Georgia"/>
-              </a:rPr>
-              <a:t>29 %</a:t>
-            </a:r>
-          </a:p>
-          <a:p>
-            <a:pPr algn="ctr">
+              <a:rPr sz="1350" b="0" i="0">
+                <a:solidFill>
+                  <a:srgbClr val="CFD6E0"/>
+                </a:solidFill>
+                <a:latin typeface="Helvetica Neue"/>
+              </a:rPr>
+              <a:t>valeur d'un client</a:t>
+            </a:r>
+          </a:p>
+        </p:txBody>
+      </p:sp>
+      <p:sp>
+        <p:nvSpPr>
+          <p:cNvPr id="12" name="TextBox 11"/>
+          <p:cNvSpPr txBox="1"/>
+          <p:nvPr/>
+        </p:nvSpPr>
+        <p:spPr>
+          <a:xfrm>
+            <a:off x="502920" y="5669280"/>
+            <a:ext cx="11185855" cy="640080"/>
+          </a:xfrm>
+          <a:prstGeom prst="rect">
+            <a:avLst/>
+          </a:prstGeom>
+          <a:noFill/>
+        </p:spPr>
+        <p:txBody>
+          <a:bodyPr wrap="square" anchor="t">
+            <a:spAutoFit/>
+          </a:bodyPr>
+          <a:lstStyle/>
+          <a:p>
+            <a:pPr algn="l">
               <a:spcBef>
                 <a:spcPts val="0"/>
               </a:spcBef>
@@ -8477,13 +9033,13 @@
               </a:spcAft>
             </a:pPr>
             <a:r>
-              <a:rPr sz="1400" b="0" i="0">
-                <a:solidFill>
-                  <a:srgbClr val="CFD6E0"/>
+              <a:rPr sz="1400" b="0" i="1">
+                <a:solidFill>
+                  <a:srgbClr val="DDD8CE"/>
                 </a:solidFill>
                 <a:latin typeface="Helvetica Neue"/>
               </a:rPr>
-              <a:t>marge à 3 ans</a:t>
+              <a:t>Choix justifié : conversion = la boutique convertit-elle ? · CAC vs LTV = acquisition rentable ? · rétention = l'abonnement tient-il ?</a:t>
             </a:r>
           </a:p>
         </p:txBody>
@@ -8687,7 +9243,7 @@
         <p:spPr>
           <a:xfrm>
             <a:off x="502920" y="566928"/>
-            <a:ext cx="7315200" cy="274320"/>
+            <a:ext cx="9144000" cy="274320"/>
           </a:xfrm>
           <a:prstGeom prst="rect">
             <a:avLst/>
@@ -8772,7 +9328,7 @@
             <a:r>
               <a:rPr sz="1800" b="0" i="0">
                 <a:solidFill>
-                  <a:srgbClr val="C9C4BA"/>
+                  <a:srgbClr val="DDD8CE"/>
                 </a:solidFill>
                 <a:latin typeface="Helvetica Neue"/>
               </a:rPr>
@@ -8980,8 +9536,8 @@
         </p:nvSpPr>
         <p:spPr>
           <a:xfrm>
-            <a:off x="914400" y="4343400"/>
-            <a:ext cx="10362895" cy="1463040"/>
+            <a:off x="914400" y="4297680"/>
+            <a:ext cx="10362895" cy="1554480"/>
           </a:xfrm>
           <a:prstGeom prst="rect">
             <a:avLst/>
@@ -9251,7 +9807,7 @@
         <p:spPr>
           <a:xfrm>
             <a:off x="502920" y="566928"/>
-            <a:ext cx="7315200" cy="274320"/>
+            <a:ext cx="9144000" cy="274320"/>
           </a:xfrm>
           <a:prstGeom prst="rect">
             <a:avLst/>
@@ -9336,7 +9892,7 @@
             <a:r>
               <a:rPr sz="1800" b="0" i="0">
                 <a:solidFill>
-                  <a:srgbClr val="777777"/>
+                  <a:srgbClr val="444444"/>
                 </a:solidFill>
                 <a:latin typeface="Helvetica Neue"/>
               </a:rPr>
@@ -9378,7 +9934,7 @@
             <a:avLst/>
           </a:prstGeom>
           <a:solidFill>
-            <a:srgbClr val="1F3A5F"/>
+            <a:srgbClr val="F3EFE8"/>
           </a:solidFill>
           <a:ln>
             <a:noFill/>
@@ -9407,50 +9963,30 @@
           </a:p>
         </p:txBody>
       </p:sp>
-      <p:sp>
-        <p:nvSpPr>
-          <p:cNvPr id="3" name="Rectangle 2"/>
-          <p:cNvSpPr/>
-          <p:nvPr/>
-        </p:nvSpPr>
-        <p:spPr>
-          <a:xfrm>
-            <a:off x="502920" y="1417320"/>
-            <a:ext cx="822960" cy="38100"/>
-          </a:xfrm>
-          <a:prstGeom prst="rect">
-            <a:avLst/>
-          </a:prstGeom>
-          <a:solidFill>
-            <a:srgbClr val="E7C87A"/>
-          </a:solidFill>
-          <a:ln>
-            <a:noFill/>
-          </a:ln>
-          <a:effectLst/>
-        </p:spPr>
-        <p:style>
-          <a:lnRef idx="1">
-            <a:schemeClr val="accent1"/>
-          </a:lnRef>
-          <a:fillRef idx="3">
-            <a:schemeClr val="accent1"/>
-          </a:fillRef>
-          <a:effectRef idx="2">
-            <a:schemeClr val="accent1"/>
-          </a:effectRef>
-          <a:fontRef idx="minor">
-            <a:schemeClr val="lt1"/>
-          </a:fontRef>
-        </p:style>
-        <p:txBody>
-          <a:bodyPr rtlCol="0" anchor="ctr"/>
-          <a:lstStyle/>
-          <a:p>
-            <a:pPr algn="ctr"/>
-          </a:p>
-        </p:txBody>
-      </p:sp>
+      <p:pic>
+        <p:nvPicPr>
+          <p:cNvPr id="3" name="Picture 2" descr="c0.jpg"/>
+          <p:cNvPicPr>
+            <a:picLocks noChangeAspect="1"/>
+          </p:cNvPicPr>
+          <p:nvPr/>
+        </p:nvPicPr>
+        <p:blipFill>
+          <a:blip r:embed="rId2"/>
+          <a:stretch>
+            <a:fillRect/>
+          </a:stretch>
+        </p:blipFill>
+        <p:spPr>
+          <a:xfrm>
+            <a:off x="7071055" y="0"/>
+            <a:ext cx="5120640" cy="6858000"/>
+          </a:xfrm>
+          <a:prstGeom prst="rect">
+            <a:avLst/>
+          </a:prstGeom>
+        </p:spPr>
+      </p:pic>
       <p:sp>
         <p:nvSpPr>
           <p:cNvPr id="4" name="TextBox 3"/>
@@ -9484,7 +10020,7 @@
             <a:r>
               <a:rPr sz="1100" b="1" i="0">
                 <a:solidFill>
-                  <a:srgbClr val="E7C87A"/>
+                  <a:srgbClr val="B08D57"/>
                 </a:solidFill>
                 <a:latin typeface="Helvetica Neue"/>
               </a:rPr>
@@ -9526,7 +10062,7 @@
             <a:r>
               <a:rPr sz="1100" b="1" i="0">
                 <a:solidFill>
-                  <a:srgbClr val="C9C4BA"/>
+                  <a:srgbClr val="777777"/>
                 </a:solidFill>
                 <a:latin typeface="Helvetica Neue"/>
               </a:rPr>
@@ -9544,7 +10080,7 @@
         <p:spPr>
           <a:xfrm>
             <a:off x="502920" y="566928"/>
-            <a:ext cx="7315200" cy="274320"/>
+            <a:ext cx="9144000" cy="274320"/>
           </a:xfrm>
           <a:prstGeom prst="rect">
             <a:avLst/>
@@ -9568,11 +10104,11 @@
             <a:r>
               <a:rPr sz="1200" b="1" i="0">
                 <a:solidFill>
-                  <a:srgbClr val="E7C87A"/>
+                  <a:srgbClr val="B08D57"/>
                 </a:solidFill>
                 <a:latin typeface="Helvetica Neue"/>
               </a:rPr>
-              <a:t>L'INSIGHT</a:t>
+              <a:t>LE CHOIX DU PRODUIT</a:t>
             </a:r>
           </a:p>
         </p:txBody>
@@ -9585,8 +10121,8 @@
         </p:nvSpPr>
         <p:spPr>
           <a:xfrm>
-            <a:off x="502920" y="1783080"/>
-            <a:ext cx="10911535" cy="4023360"/>
+            <a:off x="640080" y="1371600"/>
+            <a:ext cx="5852160" cy="4754880"/>
           </a:xfrm>
           <a:prstGeom prst="rect">
             <a:avLst/>
@@ -9594,7 +10130,7 @@
           <a:noFill/>
         </p:spPr>
         <p:txBody>
-          <a:bodyPr wrap="square" anchor="t">
+          <a:bodyPr wrap="square" anchor="ctr">
             <a:spAutoFit/>
           </a:bodyPr>
           <a:lstStyle/>
@@ -9604,17 +10140,17 @@
                 <a:spcPts val="0"/>
               </a:spcBef>
               <a:spcAft>
-                <a:spcPts val="1400"/>
-              </a:spcAft>
-            </a:pPr>
-            <a:r>
-              <a:rPr sz="4000" b="0" i="0">
-                <a:solidFill>
-                  <a:srgbClr val="FFFFFF"/>
+                <a:spcPts val="1200"/>
+              </a:spcAft>
+            </a:pPr>
+            <a:r>
+              <a:rPr sz="3200" b="0" i="0">
+                <a:solidFill>
+                  <a:srgbClr val="141414"/>
                 </a:solidFill>
                 <a:latin typeface="Georgia"/>
               </a:rPr>
-              <a:t>Un dispositif n'est efficace que s'il est porté.</a:t>
+              <a:t>Pourquoi un bijou GPS ?</a:t>
             </a:r>
           </a:p>
           <a:p>
@@ -9623,17 +10159,55 @@
                 <a:spcPts val="0"/>
               </a:spcBef>
               <a:spcAft>
-                <a:spcPts val="600"/>
-              </a:spcAft>
-            </a:pPr>
-            <a:r>
-              <a:rPr sz="1800" b="0" i="0">
-                <a:solidFill>
-                  <a:srgbClr val="C9C4BA"/>
+                <a:spcPts val="800"/>
+              </a:spcAft>
+            </a:pPr>
+            <a:r>
+              <a:rPr sz="1600" b="0" i="0">
+                <a:solidFill>
+                  <a:srgbClr val="444444"/>
                 </a:solidFill>
                 <a:latin typeface="Helvetica Neue"/>
               </a:rPr>
-              <a:t>Et il n'est porté que s'il est désirable. Toute notre démarche part de là.</a:t>
+              <a:t>Nous croisons deux besoins : la sécurité… et la désirabilité.</a:t>
+            </a:r>
+          </a:p>
+          <a:p>
+            <a:pPr algn="l">
+              <a:spcBef>
+                <a:spcPts val="0"/>
+              </a:spcBef>
+              <a:spcAft>
+                <a:spcPts val="800"/>
+              </a:spcAft>
+            </a:pPr>
+            <a:r>
+              <a:rPr sz="1600" b="0" i="0">
+                <a:solidFill>
+                  <a:srgbClr val="444444"/>
+                </a:solidFill>
+                <a:latin typeface="Helvetica Neue"/>
+              </a:rPr>
+              <a:t>Un objet qu'on porte par envie protège vraiment.</a:t>
+            </a:r>
+          </a:p>
+          <a:p>
+            <a:pPr algn="l">
+              <a:spcBef>
+                <a:spcPts val="0"/>
+              </a:spcBef>
+              <a:spcAft>
+                <a:spcPts val="800"/>
+              </a:spcAft>
+            </a:pPr>
+            <a:r>
+              <a:rPr sz="1600" b="0" i="0">
+                <a:solidFill>
+                  <a:srgbClr val="444444"/>
+                </a:solidFill>
+                <a:latin typeface="Helvetica Neue"/>
+              </a:rPr>
+              <a:t>Marché porteur, peu sensible au prix : la sécurité d'un enfant.</a:t>
             </a:r>
           </a:p>
         </p:txBody>
@@ -9837,7 +10411,7 @@
         <p:spPr>
           <a:xfrm>
             <a:off x="502920" y="566928"/>
-            <a:ext cx="7315200" cy="274320"/>
+            <a:ext cx="9144000" cy="274320"/>
           </a:xfrm>
           <a:prstGeom prst="rect">
             <a:avLst/>
@@ -9987,7 +10561,7 @@
                 </a:solidFill>
                 <a:latin typeface="Helvetica Neue"/>
               </a:rPr>
-              <a:t>Veut savoir où sont ses enfants sans culpabiliser de travailler. Achète sur Instagram et Google.</a:t>
+              <a:t>Veut savoir où sont ses enfants sans culpabiliser de travailler.</a:t>
             </a:r>
           </a:p>
         </p:txBody>
@@ -10191,7 +10765,7 @@
         <p:spPr>
           <a:xfrm>
             <a:off x="502920" y="566928"/>
-            <a:ext cx="7315200" cy="274320"/>
+            <a:ext cx="9144000" cy="274320"/>
           </a:xfrm>
           <a:prstGeom prst="rect">
             <a:avLst/>
@@ -10341,7 +10915,7 @@
                 </a:solidFill>
                 <a:latin typeface="Helvetica Neue"/>
               </a:rPr>
-              <a:t>Budget serré, métier mobile. Sensible au paiement en 3× sans frais et au bouton SOS.</a:t>
+              <a:t>Budget serré, métier mobile. Le SOS et le paiement 3× le rassurent.</a:t>
             </a:r>
           </a:p>
         </p:txBody>
@@ -10545,7 +11119,7 @@
         <p:spPr>
           <a:xfrm>
             <a:off x="502920" y="566928"/>
-            <a:ext cx="7315200" cy="274320"/>
+            <a:ext cx="9144000" cy="274320"/>
           </a:xfrm>
           <a:prstGeom prst="rect">
             <a:avLst/>
@@ -10695,7 +11269,7 @@
                 </a:solidFill>
                 <a:latin typeface="Helvetica Neue"/>
               </a:rPr>
-              <a:t>Refuse les montres « gadget ». Veut un vrai bijou : choisit le Collier JECA Lune, finition or.</a:t>
+              <a:t>Refuse les montres « gadget ». Veut un vrai bijou pour sa fille.</a:t>
             </a:r>
           </a:p>
         </p:txBody>
@@ -10720,7 +11294,7 @@
       <p:grpSpPr/>
       <p:pic>
         <p:nvPicPr>
-          <p:cNvPr id="2" name="Picture 1" descr="c0.jpg"/>
+          <p:cNvPr id="2" name="Picture 1" descr="c1.jpg"/>
           <p:cNvPicPr>
             <a:picLocks noChangeAspect="1"/>
           </p:cNvPicPr>
@@ -10835,7 +11409,7 @@
         <p:spPr>
           <a:xfrm>
             <a:off x="502920" y="566928"/>
-            <a:ext cx="7315200" cy="274320"/>
+            <a:ext cx="9144000" cy="274320"/>
           </a:xfrm>
           <a:prstGeom prst="rect">
             <a:avLst/>
@@ -10920,7 +11494,7 @@
             <a:r>
               <a:rPr sz="1700" b="0" i="0">
                 <a:solidFill>
-                  <a:srgbClr val="E8E2D6"/>
+                  <a:srgbClr val="DDD8CE"/>
                 </a:solidFill>
                 <a:latin typeface="Helvetica Neue"/>
               </a:rPr>
@@ -10949,7 +11523,7 @@
       <p:grpSpPr/>
       <p:pic>
         <p:nvPicPr>
-          <p:cNvPr id="2" name="Picture 1" descr="c1.jpg"/>
+          <p:cNvPr id="2" name="Picture 1" descr="c2.jpg"/>
           <p:cNvPicPr>
             <a:picLocks noChangeAspect="1"/>
           </p:cNvPicPr>
@@ -11064,7 +11638,7 @@
         <p:spPr>
           <a:xfrm>
             <a:off x="502920" y="566928"/>
-            <a:ext cx="7315200" cy="274320"/>
+            <a:ext cx="9144000" cy="274320"/>
           </a:xfrm>
           <a:prstGeom prst="rect">
             <a:avLst/>
@@ -11149,11 +11723,11 @@
             <a:r>
               <a:rPr sz="1700" b="0" i="0">
                 <a:solidFill>
-                  <a:srgbClr val="E8E2D6"/>
+                  <a:srgbClr val="DDD8CE"/>
                 </a:solidFill>
                 <a:latin typeface="Helvetica Neue"/>
               </a:rPr>
-              <a:t>Précision urbaine de 5 mètres, mise à jour toutes les 30 secondes — depuis l'app des parents.</a:t>
+              <a:t>Précision urbaine de 5 mètres, mise à jour toutes les 30 secondes, depuis l'app des parents.</a:t>
             </a:r>
           </a:p>
         </p:txBody>

</xml_diff>